<commit_message>
refactor: reorganizar proyecto en estructura limpia por carpetas
</commit_message>
<xml_diff>
--- a/entregables/PRESENTACION_PARCIAL3_REDNORTE.pptx
+++ b/entregables/PRESENTACION_PARCIAL3_REDNORTE.pptx
@@ -13,9 +13,8 @@
     <p:sldId id="261" r:id="rId12"/>
     <p:sldId id="262" r:id="rId13"/>
     <p:sldId id="263" r:id="rId14"/>
-    <p:sldId id="264" r:id="rId15"/>
   </p:sldIdLst>
-  <p:sldSz cx="9144000" cy="6858000" type="screen4x3"/>
+  <p:sldSz cx="12191695" cy="6858000" type="screen4x3"/>
   <p:notesSz cx="6858000" cy="9144000"/>
   <p:defaultTextStyle>
     <a:defPPr>
@@ -3089,6 +3088,14 @@
 <file path=ppt/slides/slide1.xml><?xml version="1.0" encoding="utf-8"?>
 <p:sld xmlns:a="http://schemas.openxmlformats.org/drawingml/2006/main" xmlns:p="http://schemas.openxmlformats.org/presentationml/2006/main" xmlns:r="http://schemas.openxmlformats.org/officeDocument/2006/relationships">
   <p:cSld>
+    <p:bg>
+      <p:bgPr>
+        <a:solidFill>
+          <a:srgbClr val="E7F8F7"/>
+        </a:solidFill>
+        <a:effectLst/>
+      </p:bgPr>
+    </p:bg>
     <p:spTree>
       <p:nvGrpSpPr>
         <p:cNvPr id="1" name=""/>
@@ -3098,47 +3105,377 @@
       <p:grpSpPr/>
       <p:sp>
         <p:nvSpPr>
-          <p:cNvPr id="2" name="Title 1"/>
-          <p:cNvSpPr>
-            <a:spLocks noGrp="1"/>
-          </p:cNvSpPr>
-          <p:nvPr>
-            <p:ph type="ctrTitle"/>
-          </p:nvPr>
-        </p:nvSpPr>
-        <p:spPr/>
-        <p:txBody>
-          <a:bodyPr/>
-          <a:lstStyle/>
-          <a:p>
-            <a:r>
-              <a:t>RedNorte - Parcial 3</a:t>
-            </a:r>
-          </a:p>
-        </p:txBody>
-      </p:sp>
-      <p:sp>
-        <p:nvSpPr>
-          <p:cNvPr id="3" name="Subtitle 2"/>
-          <p:cNvSpPr>
-            <a:spLocks noGrp="1"/>
-          </p:cNvSpPr>
-          <p:nvPr>
-            <p:ph type="subTitle" idx="1"/>
-          </p:nvPr>
-        </p:nvSpPr>
-        <p:spPr/>
-        <p:txBody>
-          <a:bodyPr/>
-          <a:lstStyle/>
-          <a:p>
-            <a:r>
-              <a:t>Arquitectura de microservicios, pruebas y mejoras</a:t>
-            </a:r>
-          </a:p>
-          <a:p>
-            <a:r>
-              <a:t>Fecha: 28-06-2026</a:t>
+          <p:cNvPr id="2" name="Rounded Rectangle 1"/>
+          <p:cNvSpPr/>
+          <p:nvPr/>
+        </p:nvSpPr>
+        <p:spPr>
+          <a:xfrm>
+            <a:off x="640080" y="731520"/>
+            <a:ext cx="10881360" cy="5303520"/>
+          </a:xfrm>
+          <a:prstGeom prst="roundRect">
+            <a:avLst/>
+          </a:prstGeom>
+          <a:solidFill>
+            <a:srgbClr val="FFFFFF"/>
+          </a:solidFill>
+          <a:ln>
+            <a:solidFill>
+              <a:srgbClr val="DCE6F2"/>
+            </a:solidFill>
+          </a:ln>
+        </p:spPr>
+        <p:style>
+          <a:lnRef idx="1">
+            <a:schemeClr val="accent1"/>
+          </a:lnRef>
+          <a:fillRef idx="3">
+            <a:schemeClr val="accent1"/>
+          </a:fillRef>
+          <a:effectRef idx="2">
+            <a:schemeClr val="accent1"/>
+          </a:effectRef>
+          <a:fontRef idx="minor">
+            <a:schemeClr val="lt1"/>
+          </a:fontRef>
+        </p:style>
+        <p:txBody>
+          <a:bodyPr rtlCol="0" anchor="ctr"/>
+          <a:lstStyle/>
+          <a:p>
+            <a:pPr algn="ctr"/>
+          </a:p>
+        </p:txBody>
+      </p:sp>
+      <p:sp>
+        <p:nvSpPr>
+          <p:cNvPr id="3" name="Rectangle 2"/>
+          <p:cNvSpPr/>
+          <p:nvPr/>
+        </p:nvSpPr>
+        <p:spPr>
+          <a:xfrm>
+            <a:off x="640080" y="731520"/>
+            <a:ext cx="164592" cy="5303520"/>
+          </a:xfrm>
+          <a:prstGeom prst="rect">
+            <a:avLst/>
+          </a:prstGeom>
+          <a:solidFill>
+            <a:srgbClr val="147E7C"/>
+          </a:solidFill>
+          <a:ln>
+            <a:noFill/>
+          </a:ln>
+        </p:spPr>
+        <p:style>
+          <a:lnRef idx="1">
+            <a:schemeClr val="accent1"/>
+          </a:lnRef>
+          <a:fillRef idx="3">
+            <a:schemeClr val="accent1"/>
+          </a:fillRef>
+          <a:effectRef idx="2">
+            <a:schemeClr val="accent1"/>
+          </a:effectRef>
+          <a:fontRef idx="minor">
+            <a:schemeClr val="lt1"/>
+          </a:fontRef>
+        </p:style>
+        <p:txBody>
+          <a:bodyPr rtlCol="0" anchor="ctr"/>
+          <a:lstStyle/>
+          <a:p>
+            <a:pPr algn="ctr"/>
+          </a:p>
+        </p:txBody>
+      </p:sp>
+      <p:sp>
+        <p:nvSpPr>
+          <p:cNvPr id="4" name="TextBox 3"/>
+          <p:cNvSpPr txBox="1"/>
+          <p:nvPr/>
+        </p:nvSpPr>
+        <p:spPr>
+          <a:xfrm>
+            <a:off x="960120" y="1143000"/>
+            <a:ext cx="9875520" cy="1828800"/>
+          </a:xfrm>
+          <a:prstGeom prst="rect">
+            <a:avLst/>
+          </a:prstGeom>
+          <a:noFill/>
+        </p:spPr>
+        <p:txBody>
+          <a:bodyPr wrap="none">
+            <a:spAutoFit/>
+          </a:bodyPr>
+          <a:lstStyle/>
+          <a:p>
+            <a:r>
+              <a:rPr sz="3400" b="1">
+                <a:solidFill>
+                  <a:srgbClr val="112A4A"/>
+                </a:solidFill>
+                <a:latin typeface="Aptos Display"/>
+              </a:rPr>
+              <a:t>RedNorte</a:t>
+            </a:r>
+          </a:p>
+          <a:p>
+            <a:pPr>
+              <a:defRPr sz="2400">
+                <a:solidFill>
+                  <a:srgbClr val="147E7C"/>
+                </a:solidFill>
+                <a:latin typeface="Aptos Display"/>
+              </a:defRPr>
+            </a:pPr>
+            <a:r>
+              <a:t>Plataforma de gesti?n de pacientes y citas m?dicas</a:t>
+            </a:r>
+          </a:p>
+          <a:p>
+            <a:pPr>
+              <a:defRPr sz="1400">
+                <a:solidFill>
+                  <a:srgbClr val="64748B"/>
+                </a:solidFill>
+                <a:latin typeface="Aptos"/>
+              </a:defRPr>
+            </a:pPr>
+            <a:r>
+              <a:t>Presentaci?n de apoyo al video | Arquitectura, demo funcional, APIs y pruebas</a:t>
+            </a:r>
+          </a:p>
+        </p:txBody>
+      </p:sp>
+      <p:sp>
+        <p:nvSpPr>
+          <p:cNvPr id="5" name="Rounded Rectangle 4"/>
+          <p:cNvSpPr/>
+          <p:nvPr/>
+        </p:nvSpPr>
+        <p:spPr>
+          <a:xfrm>
+            <a:off x="1005840" y="3566160"/>
+            <a:ext cx="3017520" cy="640080"/>
+          </a:xfrm>
+          <a:prstGeom prst="roundRect">
+            <a:avLst/>
+          </a:prstGeom>
+          <a:solidFill>
+            <a:srgbClr val="147E7C"/>
+          </a:solidFill>
+          <a:ln>
+            <a:noFill/>
+          </a:ln>
+        </p:spPr>
+        <p:style>
+          <a:lnRef idx="1">
+            <a:schemeClr val="accent1"/>
+          </a:lnRef>
+          <a:fillRef idx="3">
+            <a:schemeClr val="accent1"/>
+          </a:fillRef>
+          <a:effectRef idx="2">
+            <a:schemeClr val="accent1"/>
+          </a:effectRef>
+          <a:fontRef idx="minor">
+            <a:schemeClr val="lt1"/>
+          </a:fontRef>
+        </p:style>
+        <p:txBody>
+          <a:bodyPr rtlCol="0" anchor="ctr"/>
+          <a:lstStyle/>
+          <a:p>
+            <a:pPr algn="ctr">
+              <a:defRPr sz="1400" b="1">
+                <a:solidFill>
+                  <a:srgbClr val="FFFFFF"/>
+                </a:solidFill>
+                <a:latin typeface="Aptos"/>
+              </a:defRPr>
+            </a:pPr>
+            <a:r>
+              <a:t>Arquitectura de microservicios</a:t>
+            </a:r>
+          </a:p>
+        </p:txBody>
+      </p:sp>
+      <p:sp>
+        <p:nvSpPr>
+          <p:cNvPr id="6" name="Rounded Rectangle 5"/>
+          <p:cNvSpPr/>
+          <p:nvPr/>
+        </p:nvSpPr>
+        <p:spPr>
+          <a:xfrm>
+            <a:off x="4480560" y="3566160"/>
+            <a:ext cx="3017520" cy="640080"/>
+          </a:xfrm>
+          <a:prstGeom prst="roundRect">
+            <a:avLst/>
+          </a:prstGeom>
+          <a:solidFill>
+            <a:srgbClr val="F2B02D"/>
+          </a:solidFill>
+          <a:ln>
+            <a:noFill/>
+          </a:ln>
+        </p:spPr>
+        <p:style>
+          <a:lnRef idx="1">
+            <a:schemeClr val="accent1"/>
+          </a:lnRef>
+          <a:fillRef idx="3">
+            <a:schemeClr val="accent1"/>
+          </a:fillRef>
+          <a:effectRef idx="2">
+            <a:schemeClr val="accent1"/>
+          </a:effectRef>
+          <a:fontRef idx="minor">
+            <a:schemeClr val="lt1"/>
+          </a:fontRef>
+        </p:style>
+        <p:txBody>
+          <a:bodyPr rtlCol="0" anchor="ctr"/>
+          <a:lstStyle/>
+          <a:p>
+            <a:pPr algn="ctr">
+              <a:defRPr sz="1400" b="1">
+                <a:solidFill>
+                  <a:srgbClr val="FFFFFF"/>
+                </a:solidFill>
+                <a:latin typeface="Aptos"/>
+              </a:defRPr>
+            </a:pPr>
+            <a:r>
+              <a:t>Flujo cl?nico completo</a:t>
+            </a:r>
+          </a:p>
+        </p:txBody>
+      </p:sp>
+      <p:sp>
+        <p:nvSpPr>
+          <p:cNvPr id="7" name="Rounded Rectangle 6"/>
+          <p:cNvSpPr/>
+          <p:nvPr/>
+        </p:nvSpPr>
+        <p:spPr>
+          <a:xfrm>
+            <a:off x="7955279" y="3566160"/>
+            <a:ext cx="3017520" cy="640080"/>
+          </a:xfrm>
+          <a:prstGeom prst="roundRect">
+            <a:avLst/>
+          </a:prstGeom>
+          <a:solidFill>
+            <a:srgbClr val="112A4A"/>
+          </a:solidFill>
+          <a:ln>
+            <a:noFill/>
+          </a:ln>
+        </p:spPr>
+        <p:style>
+          <a:lnRef idx="1">
+            <a:schemeClr val="accent1"/>
+          </a:lnRef>
+          <a:fillRef idx="3">
+            <a:schemeClr val="accent1"/>
+          </a:fillRef>
+          <a:effectRef idx="2">
+            <a:schemeClr val="accent1"/>
+          </a:effectRef>
+          <a:fontRef idx="minor">
+            <a:schemeClr val="lt1"/>
+          </a:fontRef>
+        </p:style>
+        <p:txBody>
+          <a:bodyPr rtlCol="0" anchor="ctr"/>
+          <a:lstStyle/>
+          <a:p>
+            <a:pPr algn="ctr">
+              <a:defRPr sz="1400" b="1">
+                <a:solidFill>
+                  <a:srgbClr val="FFFFFF"/>
+                </a:solidFill>
+                <a:latin typeface="Aptos"/>
+              </a:defRPr>
+            </a:pPr>
+            <a:r>
+              <a:t>Pruebas verificables</a:t>
+            </a:r>
+          </a:p>
+        </p:txBody>
+      </p:sp>
+      <p:sp>
+        <p:nvSpPr>
+          <p:cNvPr id="8" name="TextBox 7"/>
+          <p:cNvSpPr txBox="1"/>
+          <p:nvPr/>
+        </p:nvSpPr>
+        <p:spPr>
+          <a:xfrm>
+            <a:off x="1005840" y="4754880"/>
+            <a:ext cx="9875520" cy="640080"/>
+          </a:xfrm>
+          <a:prstGeom prst="rect">
+            <a:avLst/>
+          </a:prstGeom>
+          <a:noFill/>
+        </p:spPr>
+        <p:txBody>
+          <a:bodyPr wrap="none">
+            <a:spAutoFit/>
+          </a:bodyPr>
+          <a:lstStyle/>
+          <a:p>
+            <a:pPr>
+              <a:defRPr sz="1400">
+                <a:solidFill>
+                  <a:srgbClr val="64748B"/>
+                </a:solidFill>
+              </a:defRPr>
+            </a:pPr>
+            <a:r>
+              <a:t>Objetivo: demostrar valor operativo, funcionamiento real y evidencia t?cnica alineada a la pauta de evaluaci?n.</a:t>
+            </a:r>
+          </a:p>
+        </p:txBody>
+      </p:sp>
+      <p:sp>
+        <p:nvSpPr>
+          <p:cNvPr id="9" name="TextBox 8"/>
+          <p:cNvSpPr txBox="1"/>
+          <p:nvPr/>
+        </p:nvSpPr>
+        <p:spPr>
+          <a:xfrm>
+            <a:off x="502920" y="6400800"/>
+            <a:ext cx="10972800" cy="228600"/>
+          </a:xfrm>
+          <a:prstGeom prst="rect">
+            <a:avLst/>
+          </a:prstGeom>
+          <a:noFill/>
+        </p:spPr>
+        <p:txBody>
+          <a:bodyPr wrap="none">
+            <a:spAutoFit/>
+          </a:bodyPr>
+          <a:lstStyle/>
+          <a:p>
+            <a:pPr algn="r">
+              <a:defRPr sz="900">
+                <a:solidFill>
+                  <a:srgbClr val="64748B"/>
+                </a:solidFill>
+              </a:defRPr>
+            </a:pPr>
+            <a:r>
+              <a:t>RedNorte | Parcial 3</a:t>
             </a:r>
           </a:p>
         </p:txBody>
@@ -3154,6 +3491,14 @@
 <file path=ppt/slides/slide2.xml><?xml version="1.0" encoding="utf-8"?>
 <p:sld xmlns:a="http://schemas.openxmlformats.org/drawingml/2006/main" xmlns:p="http://schemas.openxmlformats.org/presentationml/2006/main" xmlns:r="http://schemas.openxmlformats.org/officeDocument/2006/relationships">
   <p:cSld>
+    <p:bg>
+      <p:bgPr>
+        <a:solidFill>
+          <a:srgbClr val="FFFFFF"/>
+        </a:solidFill>
+        <a:effectLst/>
+      </p:bgPr>
+    </p:bg>
     <p:spTree>
       <p:nvGrpSpPr>
         <p:cNvPr id="1" name=""/>
@@ -3163,57 +3508,362 @@
       <p:grpSpPr/>
       <p:sp>
         <p:nvSpPr>
-          <p:cNvPr id="2" name="Title 1"/>
-          <p:cNvSpPr>
-            <a:spLocks noGrp="1"/>
-          </p:cNvSpPr>
-          <p:nvPr>
-            <p:ph type="title"/>
-          </p:nvPr>
-        </p:nvSpPr>
-        <p:spPr/>
-        <p:txBody>
-          <a:bodyPr/>
-          <a:lstStyle/>
-          <a:p>
-            <a:r>
-              <a:t>1. Arquitectura</a:t>
-            </a:r>
-          </a:p>
-        </p:txBody>
-      </p:sp>
-      <p:sp>
-        <p:nvSpPr>
-          <p:cNvPr id="3" name="Content Placeholder 2"/>
-          <p:cNvSpPr>
-            <a:spLocks noGrp="1"/>
-          </p:cNvSpPr>
-          <p:nvPr>
-            <p:ph idx="1"/>
-          </p:nvPr>
-        </p:nvSpPr>
-        <p:spPr/>
-        <p:txBody>
-          <a:bodyPr/>
-          <a:lstStyle/>
-          <a:p>
-            <a:r>
-              <a:t>Frontend React + Vite (5173)</a:t>
-            </a:r>
-          </a:p>
-          <a:p>
-            <a:r>
-              <a:t>BFF Spring Boot (8080)</a:t>
-            </a:r>
-          </a:p>
-          <a:p>
-            <a:r>
-              <a:t>ms-pacientes (8081) y ms-citas (8082)</a:t>
-            </a:r>
-          </a:p>
-          <a:p>
-            <a:r>
-              <a:t>Service discovery con Eureka (8761)</a:t>
+          <p:cNvPr id="2" name="Rectangle 1"/>
+          <p:cNvSpPr/>
+          <p:nvPr/>
+        </p:nvSpPr>
+        <p:spPr>
+          <a:xfrm>
+            <a:off x="0" y="0"/>
+            <a:ext cx="12191695" cy="685800"/>
+          </a:xfrm>
+          <a:prstGeom prst="rect">
+            <a:avLst/>
+          </a:prstGeom>
+          <a:solidFill>
+            <a:srgbClr val="112A4A"/>
+          </a:solidFill>
+          <a:ln>
+            <a:noFill/>
+          </a:ln>
+        </p:spPr>
+        <p:style>
+          <a:lnRef idx="1">
+            <a:schemeClr val="accent1"/>
+          </a:lnRef>
+          <a:fillRef idx="3">
+            <a:schemeClr val="accent1"/>
+          </a:fillRef>
+          <a:effectRef idx="2">
+            <a:schemeClr val="accent1"/>
+          </a:effectRef>
+          <a:fontRef idx="minor">
+            <a:schemeClr val="lt1"/>
+          </a:fontRef>
+        </p:style>
+        <p:txBody>
+          <a:bodyPr rtlCol="0" anchor="ctr"/>
+          <a:lstStyle/>
+          <a:p>
+            <a:pPr algn="ctr"/>
+          </a:p>
+        </p:txBody>
+      </p:sp>
+      <p:sp>
+        <p:nvSpPr>
+          <p:cNvPr id="3" name="TextBox 2"/>
+          <p:cNvSpPr txBox="1"/>
+          <p:nvPr/>
+        </p:nvSpPr>
+        <p:spPr>
+          <a:xfrm>
+            <a:off x="502920" y="109728"/>
+            <a:ext cx="9875520" cy="411480"/>
+          </a:xfrm>
+          <a:prstGeom prst="rect">
+            <a:avLst/>
+          </a:prstGeom>
+          <a:noFill/>
+        </p:spPr>
+        <p:txBody>
+          <a:bodyPr wrap="none">
+            <a:spAutoFit/>
+          </a:bodyPr>
+          <a:lstStyle/>
+          <a:p>
+            <a:r>
+              <a:rPr sz="2400" b="1">
+                <a:solidFill>
+                  <a:srgbClr val="FFFFFF"/>
+                </a:solidFill>
+                <a:latin typeface="Aptos Display"/>
+              </a:rPr>
+              <a:t>Problema y valor de negocio</a:t>
+            </a:r>
+          </a:p>
+          <a:p>
+            <a:pPr algn="r">
+              <a:defRPr sz="1050">
+                <a:solidFill>
+                  <a:srgbClr val="D7E2F0"/>
+                </a:solidFill>
+                <a:latin typeface="Aptos"/>
+              </a:defRPr>
+            </a:pPr>
+            <a:r>
+              <a:t>Por qu? RedNorte importa</a:t>
+            </a:r>
+          </a:p>
+        </p:txBody>
+      </p:sp>
+      <p:sp>
+        <p:nvSpPr>
+          <p:cNvPr id="4" name="TextBox 3"/>
+          <p:cNvSpPr txBox="1"/>
+          <p:nvPr/>
+        </p:nvSpPr>
+        <p:spPr>
+          <a:xfrm>
+            <a:off x="731520" y="1097280"/>
+            <a:ext cx="5303520" cy="384048"/>
+          </a:xfrm>
+          <a:prstGeom prst="rect">
+            <a:avLst/>
+          </a:prstGeom>
+          <a:noFill/>
+        </p:spPr>
+        <p:txBody>
+          <a:bodyPr wrap="none">
+            <a:spAutoFit/>
+          </a:bodyPr>
+          <a:lstStyle/>
+          <a:p>
+            <a:pPr>
+              <a:defRPr sz="2000" b="1">
+                <a:solidFill>
+                  <a:srgbClr val="147E7C"/>
+                </a:solidFill>
+                <a:latin typeface="Aptos Display"/>
+              </a:defRPr>
+            </a:pPr>
+            <a:r>
+              <a:t>Dolores que resuelve</a:t>
+            </a:r>
+          </a:p>
+        </p:txBody>
+      </p:sp>
+      <p:sp>
+        <p:nvSpPr>
+          <p:cNvPr id="5" name="TextBox 4"/>
+          <p:cNvSpPr txBox="1"/>
+          <p:nvPr/>
+        </p:nvSpPr>
+        <p:spPr>
+          <a:xfrm>
+            <a:off x="731520" y="1554480"/>
+            <a:ext cx="5303520" cy="4480560"/>
+          </a:xfrm>
+          <a:prstGeom prst="rect">
+            <a:avLst/>
+          </a:prstGeom>
+          <a:noFill/>
+        </p:spPr>
+        <p:txBody>
+          <a:bodyPr wrap="square" lIns="0" rIns="0" tIns="0" anchor="t">
+            <a:spAutoFit/>
+          </a:bodyPr>
+          <a:lstStyle/>
+          <a:p>
+            <a:pPr>
+              <a:spcAft>
+                <a:spcPts val="800"/>
+              </a:spcAft>
+              <a:defRPr sz="1600">
+                <a:solidFill>
+                  <a:srgbClr val="1E293B"/>
+                </a:solidFill>
+                <a:latin typeface="Aptos"/>
+              </a:defRPr>
+            </a:pPr>
+            <a:r>
+              <a:t>Registro lento y disperso de pacientes.</a:t>
+            </a:r>
+          </a:p>
+          <a:p>
+            <a:pPr>
+              <a:spcAft>
+                <a:spcPts val="800"/>
+              </a:spcAft>
+              <a:defRPr sz="1600">
+                <a:solidFill>
+                  <a:srgbClr val="1E293B"/>
+                </a:solidFill>
+                <a:latin typeface="Aptos"/>
+              </a:defRPr>
+            </a:pPr>
+            <a:r>
+              <a:t>Duplicidad de informaci?n entre procesos.</a:t>
+            </a:r>
+          </a:p>
+          <a:p>
+            <a:pPr>
+              <a:spcAft>
+                <a:spcPts val="800"/>
+              </a:spcAft>
+              <a:defRPr sz="1600">
+                <a:solidFill>
+                  <a:srgbClr val="1E293B"/>
+                </a:solidFill>
+                <a:latin typeface="Aptos"/>
+              </a:defRPr>
+            </a:pPr>
+            <a:r>
+              <a:t>Baja visibilidad de la atenci?n y la agenda.</a:t>
+            </a:r>
+          </a:p>
+          <a:p>
+            <a:pPr>
+              <a:spcAft>
+                <a:spcPts val="800"/>
+              </a:spcAft>
+              <a:defRPr sz="1600">
+                <a:solidFill>
+                  <a:srgbClr val="1E293B"/>
+                </a:solidFill>
+                <a:latin typeface="Aptos"/>
+              </a:defRPr>
+            </a:pPr>
+            <a:r>
+              <a:t>Necesidad de evidencia t?cnica y trazabilidad.</a:t>
+            </a:r>
+          </a:p>
+        </p:txBody>
+      </p:sp>
+      <p:sp>
+        <p:nvSpPr>
+          <p:cNvPr id="6" name="Rounded Rectangle 5"/>
+          <p:cNvSpPr/>
+          <p:nvPr/>
+        </p:nvSpPr>
+        <p:spPr>
+          <a:xfrm>
+            <a:off x="6309360" y="1143000"/>
+            <a:ext cx="5120640" cy="4663440"/>
+          </a:xfrm>
+          <a:prstGeom prst="roundRect">
+            <a:avLst/>
+          </a:prstGeom>
+          <a:solidFill>
+            <a:srgbClr val="F5F8FC"/>
+          </a:solidFill>
+          <a:ln>
+            <a:solidFill>
+              <a:srgbClr val="DCE6F2"/>
+            </a:solidFill>
+          </a:ln>
+        </p:spPr>
+        <p:style>
+          <a:lnRef idx="1">
+            <a:schemeClr val="accent1"/>
+          </a:lnRef>
+          <a:fillRef idx="3">
+            <a:schemeClr val="accent1"/>
+          </a:fillRef>
+          <a:effectRef idx="2">
+            <a:schemeClr val="accent1"/>
+          </a:effectRef>
+          <a:fontRef idx="minor">
+            <a:schemeClr val="lt1"/>
+          </a:fontRef>
+        </p:style>
+        <p:txBody>
+          <a:bodyPr rtlCol="0" anchor="ctr" lIns="228600" rIns="228600" tIns="182880"/>
+          <a:lstStyle/>
+          <a:p>
+            <a:pPr algn="ctr">
+              <a:defRPr sz="2000" b="1">
+                <a:solidFill>
+                  <a:srgbClr val="112A4A"/>
+                </a:solidFill>
+              </a:defRPr>
+            </a:pPr>
+            <a:r>
+              <a:t>Propuesta</a:t>
+            </a:r>
+          </a:p>
+          <a:p>
+            <a:pPr>
+              <a:spcAft>
+                <a:spcPts val="1000"/>
+              </a:spcAft>
+              <a:defRPr sz="1700">
+                <a:solidFill>
+                  <a:srgbClr val="1E293B"/>
+                </a:solidFill>
+              </a:defRPr>
+            </a:pPr>
+            <a:r>
+              <a:t>Centralizar pacientes y citas en una sola plataforma.</a:t>
+            </a:r>
+          </a:p>
+          <a:p>
+            <a:pPr>
+              <a:spcAft>
+                <a:spcPts val="1000"/>
+              </a:spcAft>
+              <a:defRPr sz="1700">
+                <a:solidFill>
+                  <a:srgbClr val="1E293B"/>
+                </a:solidFill>
+              </a:defRPr>
+            </a:pPr>
+            <a:r>
+              <a:t>Disminuir fricci?n operativa en la gesti?n diaria.</a:t>
+            </a:r>
+          </a:p>
+          <a:p>
+            <a:pPr>
+              <a:spcAft>
+                <a:spcPts val="1000"/>
+              </a:spcAft>
+              <a:defRPr sz="1700">
+                <a:solidFill>
+                  <a:srgbClr val="1E293B"/>
+                </a:solidFill>
+              </a:defRPr>
+            </a:pPr>
+            <a:r>
+              <a:t>Soportar procesos cr?ticos con APIs y pruebas reales.</a:t>
+            </a:r>
+          </a:p>
+          <a:p>
+            <a:pPr>
+              <a:spcAft>
+                <a:spcPts val="1000"/>
+              </a:spcAft>
+              <a:defRPr sz="1700">
+                <a:solidFill>
+                  <a:srgbClr val="1E293B"/>
+                </a:solidFill>
+              </a:defRPr>
+            </a:pPr>
+            <a:r>
+              <a:t>Dejar una base escalable para futuras mejoras.</a:t>
+            </a:r>
+          </a:p>
+        </p:txBody>
+      </p:sp>
+      <p:sp>
+        <p:nvSpPr>
+          <p:cNvPr id="7" name="TextBox 6"/>
+          <p:cNvSpPr txBox="1"/>
+          <p:nvPr/>
+        </p:nvSpPr>
+        <p:spPr>
+          <a:xfrm>
+            <a:off x="502920" y="6400800"/>
+            <a:ext cx="10972800" cy="228600"/>
+          </a:xfrm>
+          <a:prstGeom prst="rect">
+            <a:avLst/>
+          </a:prstGeom>
+          <a:noFill/>
+        </p:spPr>
+        <p:txBody>
+          <a:bodyPr wrap="none">
+            <a:spAutoFit/>
+          </a:bodyPr>
+          <a:lstStyle/>
+          <a:p>
+            <a:pPr algn="r">
+              <a:defRPr sz="900">
+                <a:solidFill>
+                  <a:srgbClr val="64748B"/>
+                </a:solidFill>
+              </a:defRPr>
+            </a:pPr>
+            <a:r>
+              <a:t>RedNorte | Parcial 3</a:t>
             </a:r>
           </a:p>
         </p:txBody>
@@ -3229,6 +3879,14 @@
 <file path=ppt/slides/slide3.xml><?xml version="1.0" encoding="utf-8"?>
 <p:sld xmlns:a="http://schemas.openxmlformats.org/drawingml/2006/main" xmlns:p="http://schemas.openxmlformats.org/presentationml/2006/main" xmlns:r="http://schemas.openxmlformats.org/officeDocument/2006/relationships">
   <p:cSld>
+    <p:bg>
+      <p:bgPr>
+        <a:solidFill>
+          <a:srgbClr val="FFFFFF"/>
+        </a:solidFill>
+        <a:effectLst/>
+      </p:bgPr>
+    </p:bg>
     <p:spTree>
       <p:nvGrpSpPr>
         <p:cNvPr id="1" name=""/>
@@ -3238,62 +3896,569 @@
       <p:grpSpPr/>
       <p:sp>
         <p:nvSpPr>
-          <p:cNvPr id="2" name="Title 1"/>
-          <p:cNvSpPr>
-            <a:spLocks noGrp="1"/>
-          </p:cNvSpPr>
-          <p:nvPr>
-            <p:ph type="title"/>
-          </p:nvPr>
-        </p:nvSpPr>
-        <p:spPr/>
-        <p:txBody>
-          <a:bodyPr/>
-          <a:lstStyle/>
-          <a:p>
-            <a:r>
-              <a:t>2. Business Core</a:t>
-            </a:r>
-          </a:p>
-        </p:txBody>
-      </p:sp>
-      <p:sp>
-        <p:nvSpPr>
-          <p:cNvPr id="3" name="Content Placeholder 2"/>
-          <p:cNvSpPr>
-            <a:spLocks noGrp="1"/>
-          </p:cNvSpPr>
-          <p:nvPr>
-            <p:ph idx="1"/>
-          </p:nvPr>
-        </p:nvSpPr>
-        <p:spPr/>
-        <p:txBody>
-          <a:bodyPr/>
-          <a:lstStyle/>
-          <a:p>
-            <a:r>
-              <a:t>Alta de paciente</a:t>
-            </a:r>
-          </a:p>
-          <a:p>
-            <a:r>
-              <a:t>Actualizacion de paciente</a:t>
-            </a:r>
-          </a:p>
-          <a:p>
-            <a:r>
-              <a:t>Alta de cita asociada</a:t>
-            </a:r>
-          </a:p>
-          <a:p>
-            <a:r>
-              <a:t>Consulta de citas</a:t>
-            </a:r>
-          </a:p>
-          <a:p>
-            <a:r>
-              <a:t>Eliminacion y consistencia</a:t>
+          <p:cNvPr id="2" name="Rectangle 1"/>
+          <p:cNvSpPr/>
+          <p:nvPr/>
+        </p:nvSpPr>
+        <p:spPr>
+          <a:xfrm>
+            <a:off x="0" y="0"/>
+            <a:ext cx="12191695" cy="685800"/>
+          </a:xfrm>
+          <a:prstGeom prst="rect">
+            <a:avLst/>
+          </a:prstGeom>
+          <a:solidFill>
+            <a:srgbClr val="112A4A"/>
+          </a:solidFill>
+          <a:ln>
+            <a:noFill/>
+          </a:ln>
+        </p:spPr>
+        <p:style>
+          <a:lnRef idx="1">
+            <a:schemeClr val="accent1"/>
+          </a:lnRef>
+          <a:fillRef idx="3">
+            <a:schemeClr val="accent1"/>
+          </a:fillRef>
+          <a:effectRef idx="2">
+            <a:schemeClr val="accent1"/>
+          </a:effectRef>
+          <a:fontRef idx="minor">
+            <a:schemeClr val="lt1"/>
+          </a:fontRef>
+        </p:style>
+        <p:txBody>
+          <a:bodyPr rtlCol="0" anchor="ctr"/>
+          <a:lstStyle/>
+          <a:p>
+            <a:pPr algn="ctr"/>
+          </a:p>
+        </p:txBody>
+      </p:sp>
+      <p:sp>
+        <p:nvSpPr>
+          <p:cNvPr id="3" name="TextBox 2"/>
+          <p:cNvSpPr txBox="1"/>
+          <p:nvPr/>
+        </p:nvSpPr>
+        <p:spPr>
+          <a:xfrm>
+            <a:off x="502920" y="109728"/>
+            <a:ext cx="9875520" cy="411480"/>
+          </a:xfrm>
+          <a:prstGeom prst="rect">
+            <a:avLst/>
+          </a:prstGeom>
+          <a:noFill/>
+        </p:spPr>
+        <p:txBody>
+          <a:bodyPr wrap="none">
+            <a:spAutoFit/>
+          </a:bodyPr>
+          <a:lstStyle/>
+          <a:p>
+            <a:r>
+              <a:rPr sz="2400" b="1">
+                <a:solidFill>
+                  <a:srgbClr val="FFFFFF"/>
+                </a:solidFill>
+                <a:latin typeface="Aptos Display"/>
+              </a:rPr>
+              <a:t>Arquitectura de la soluci?n</a:t>
+            </a:r>
+          </a:p>
+          <a:p>
+            <a:pPr algn="r">
+              <a:defRPr sz="1050">
+                <a:solidFill>
+                  <a:srgbClr val="D7E2F0"/>
+                </a:solidFill>
+                <a:latin typeface="Aptos"/>
+              </a:defRPr>
+            </a:pPr>
+            <a:r>
+              <a:t>Separaci?n clara de responsabilidades</a:t>
+            </a:r>
+          </a:p>
+        </p:txBody>
+      </p:sp>
+      <p:sp>
+        <p:nvSpPr>
+          <p:cNvPr id="4" name="Rounded Rectangle 3"/>
+          <p:cNvSpPr/>
+          <p:nvPr/>
+        </p:nvSpPr>
+        <p:spPr>
+          <a:xfrm>
+            <a:off x="777240" y="1828800"/>
+            <a:ext cx="2148840" cy="1005840"/>
+          </a:xfrm>
+          <a:prstGeom prst="roundRect">
+            <a:avLst/>
+          </a:prstGeom>
+          <a:solidFill>
+            <a:srgbClr val="E7F8F7"/>
+          </a:solidFill>
+          <a:ln>
+            <a:solidFill>
+              <a:srgbClr val="112A4A"/>
+            </a:solidFill>
+          </a:ln>
+        </p:spPr>
+        <p:style>
+          <a:lnRef idx="1">
+            <a:schemeClr val="accent1"/>
+          </a:lnRef>
+          <a:fillRef idx="3">
+            <a:schemeClr val="accent1"/>
+          </a:fillRef>
+          <a:effectRef idx="2">
+            <a:schemeClr val="accent1"/>
+          </a:effectRef>
+          <a:fontRef idx="minor">
+            <a:schemeClr val="lt1"/>
+          </a:fontRef>
+        </p:style>
+        <p:txBody>
+          <a:bodyPr rtlCol="0" anchor="ctr"/>
+          <a:lstStyle/>
+          <a:p>
+            <a:pPr algn="ctr">
+              <a:defRPr sz="1600" b="1">
+                <a:solidFill>
+                  <a:srgbClr val="112A4A"/>
+                </a:solidFill>
+              </a:defRPr>
+            </a:pPr>
+            <a:r>
+              <a:t>Frontend React</a:t>
+            </a:r>
+          </a:p>
+        </p:txBody>
+      </p:sp>
+      <p:sp>
+        <p:nvSpPr>
+          <p:cNvPr id="5" name="Rounded Rectangle 4"/>
+          <p:cNvSpPr/>
+          <p:nvPr/>
+        </p:nvSpPr>
+        <p:spPr>
+          <a:xfrm>
+            <a:off x="3429000" y="1828800"/>
+            <a:ext cx="2148840" cy="1005840"/>
+          </a:xfrm>
+          <a:prstGeom prst="roundRect">
+            <a:avLst/>
+          </a:prstGeom>
+          <a:solidFill>
+            <a:srgbClr val="E2F8F7"/>
+          </a:solidFill>
+          <a:ln>
+            <a:solidFill>
+              <a:srgbClr val="147E7C"/>
+            </a:solidFill>
+          </a:ln>
+        </p:spPr>
+        <p:style>
+          <a:lnRef idx="1">
+            <a:schemeClr val="accent1"/>
+          </a:lnRef>
+          <a:fillRef idx="3">
+            <a:schemeClr val="accent1"/>
+          </a:fillRef>
+          <a:effectRef idx="2">
+            <a:schemeClr val="accent1"/>
+          </a:effectRef>
+          <a:fontRef idx="minor">
+            <a:schemeClr val="lt1"/>
+          </a:fontRef>
+        </p:style>
+        <p:txBody>
+          <a:bodyPr rtlCol="0" anchor="ctr"/>
+          <a:lstStyle/>
+          <a:p>
+            <a:pPr algn="ctr">
+              <a:defRPr sz="1600" b="1">
+                <a:solidFill>
+                  <a:srgbClr val="147E7C"/>
+                </a:solidFill>
+              </a:defRPr>
+            </a:pPr>
+            <a:r>
+              <a:t>BFF Spring Boot</a:t>
+            </a:r>
+          </a:p>
+        </p:txBody>
+      </p:sp>
+      <p:sp>
+        <p:nvSpPr>
+          <p:cNvPr id="6" name="Rounded Rectangle 5"/>
+          <p:cNvSpPr/>
+          <p:nvPr/>
+        </p:nvSpPr>
+        <p:spPr>
+          <a:xfrm>
+            <a:off x="6080760" y="1828800"/>
+            <a:ext cx="2148840" cy="1005840"/>
+          </a:xfrm>
+          <a:prstGeom prst="roundRect">
+            <a:avLst/>
+          </a:prstGeom>
+          <a:solidFill>
+            <a:srgbClr val="FFF4E0"/>
+          </a:solidFill>
+          <a:ln>
+            <a:solidFill>
+              <a:srgbClr val="F2B02D"/>
+            </a:solidFill>
+          </a:ln>
+        </p:spPr>
+        <p:style>
+          <a:lnRef idx="1">
+            <a:schemeClr val="accent1"/>
+          </a:lnRef>
+          <a:fillRef idx="3">
+            <a:schemeClr val="accent1"/>
+          </a:fillRef>
+          <a:effectRef idx="2">
+            <a:schemeClr val="accent1"/>
+          </a:effectRef>
+          <a:fontRef idx="minor">
+            <a:schemeClr val="lt1"/>
+          </a:fontRef>
+        </p:style>
+        <p:txBody>
+          <a:bodyPr rtlCol="0" anchor="ctr"/>
+          <a:lstStyle/>
+          <a:p>
+            <a:pPr algn="ctr">
+              <a:defRPr sz="1600" b="1">
+                <a:solidFill>
+                  <a:srgbClr val="F2B02D"/>
+                </a:solidFill>
+              </a:defRPr>
+            </a:pPr>
+            <a:r>
+              <a:t>Ms. Pacientes</a:t>
+            </a:r>
+          </a:p>
+        </p:txBody>
+      </p:sp>
+      <p:sp>
+        <p:nvSpPr>
+          <p:cNvPr id="7" name="Rounded Rectangle 6"/>
+          <p:cNvSpPr/>
+          <p:nvPr/>
+        </p:nvSpPr>
+        <p:spPr>
+          <a:xfrm>
+            <a:off x="8732520" y="1828800"/>
+            <a:ext cx="2148840" cy="1005840"/>
+          </a:xfrm>
+          <a:prstGeom prst="roundRect">
+            <a:avLst/>
+          </a:prstGeom>
+          <a:solidFill>
+            <a:srgbClr val="ECF2FF"/>
+          </a:solidFill>
+          <a:ln>
+            <a:solidFill>
+              <a:srgbClr val="112A4A"/>
+            </a:solidFill>
+          </a:ln>
+        </p:spPr>
+        <p:style>
+          <a:lnRef idx="1">
+            <a:schemeClr val="accent1"/>
+          </a:lnRef>
+          <a:fillRef idx="3">
+            <a:schemeClr val="accent1"/>
+          </a:fillRef>
+          <a:effectRef idx="2">
+            <a:schemeClr val="accent1"/>
+          </a:effectRef>
+          <a:fontRef idx="minor">
+            <a:schemeClr val="lt1"/>
+          </a:fontRef>
+        </p:style>
+        <p:txBody>
+          <a:bodyPr rtlCol="0" anchor="ctr"/>
+          <a:lstStyle/>
+          <a:p>
+            <a:pPr algn="ctr">
+              <a:defRPr sz="1600" b="1">
+                <a:solidFill>
+                  <a:srgbClr val="112A4A"/>
+                </a:solidFill>
+              </a:defRPr>
+            </a:pPr>
+            <a:r>
+              <a:t>Ms. Citas</a:t>
+            </a:r>
+          </a:p>
+        </p:txBody>
+      </p:sp>
+      <p:sp>
+        <p:nvSpPr>
+          <p:cNvPr id="8" name="TextBox 7"/>
+          <p:cNvSpPr txBox="1"/>
+          <p:nvPr/>
+        </p:nvSpPr>
+        <p:spPr>
+          <a:xfrm>
+            <a:off x="2926080" y="2148840"/>
+            <a:ext cx="365760" cy="365760"/>
+          </a:xfrm>
+          <a:prstGeom prst="rect">
+            <a:avLst/>
+          </a:prstGeom>
+          <a:noFill/>
+        </p:spPr>
+        <p:txBody>
+          <a:bodyPr wrap="none">
+            <a:spAutoFit/>
+          </a:bodyPr>
+          <a:lstStyle/>
+          <a:p>
+            <a:pPr algn="ctr">
+              <a:defRPr sz="2600" b="1">
+                <a:solidFill>
+                  <a:srgbClr val="64748B"/>
+                </a:solidFill>
+              </a:defRPr>
+            </a:pPr>
+            <a:r>
+              <a:t>?</a:t>
+            </a:r>
+          </a:p>
+        </p:txBody>
+      </p:sp>
+      <p:sp>
+        <p:nvSpPr>
+          <p:cNvPr id="9" name="TextBox 8"/>
+          <p:cNvSpPr txBox="1"/>
+          <p:nvPr/>
+        </p:nvSpPr>
+        <p:spPr>
+          <a:xfrm>
+            <a:off x="5577840" y="2148840"/>
+            <a:ext cx="365760" cy="365760"/>
+          </a:xfrm>
+          <a:prstGeom prst="rect">
+            <a:avLst/>
+          </a:prstGeom>
+          <a:noFill/>
+        </p:spPr>
+        <p:txBody>
+          <a:bodyPr wrap="none">
+            <a:spAutoFit/>
+          </a:bodyPr>
+          <a:lstStyle/>
+          <a:p>
+            <a:pPr algn="ctr">
+              <a:defRPr sz="2600" b="1">
+                <a:solidFill>
+                  <a:srgbClr val="64748B"/>
+                </a:solidFill>
+              </a:defRPr>
+            </a:pPr>
+            <a:r>
+              <a:t>?</a:t>
+            </a:r>
+          </a:p>
+        </p:txBody>
+      </p:sp>
+      <p:sp>
+        <p:nvSpPr>
+          <p:cNvPr id="10" name="TextBox 9"/>
+          <p:cNvSpPr txBox="1"/>
+          <p:nvPr/>
+        </p:nvSpPr>
+        <p:spPr>
+          <a:xfrm>
+            <a:off x="8229600" y="2148840"/>
+            <a:ext cx="365760" cy="365760"/>
+          </a:xfrm>
+          <a:prstGeom prst="rect">
+            <a:avLst/>
+          </a:prstGeom>
+          <a:noFill/>
+        </p:spPr>
+        <p:txBody>
+          <a:bodyPr wrap="none">
+            <a:spAutoFit/>
+          </a:bodyPr>
+          <a:lstStyle/>
+          <a:p>
+            <a:pPr algn="ctr">
+              <a:defRPr sz="2600" b="1">
+                <a:solidFill>
+                  <a:srgbClr val="64748B"/>
+                </a:solidFill>
+              </a:defRPr>
+            </a:pPr>
+            <a:r>
+              <a:t>?</a:t>
+            </a:r>
+          </a:p>
+        </p:txBody>
+      </p:sp>
+      <p:sp>
+        <p:nvSpPr>
+          <p:cNvPr id="11" name="TextBox 10"/>
+          <p:cNvSpPr txBox="1"/>
+          <p:nvPr/>
+        </p:nvSpPr>
+        <p:spPr>
+          <a:xfrm>
+            <a:off x="731520" y="3474720"/>
+            <a:ext cx="10972800" cy="384048"/>
+          </a:xfrm>
+          <a:prstGeom prst="rect">
+            <a:avLst/>
+          </a:prstGeom>
+          <a:noFill/>
+        </p:spPr>
+        <p:txBody>
+          <a:bodyPr wrap="none">
+            <a:spAutoFit/>
+          </a:bodyPr>
+          <a:lstStyle/>
+          <a:p>
+            <a:pPr>
+              <a:defRPr sz="2000" b="1">
+                <a:solidFill>
+                  <a:srgbClr val="147E7C"/>
+                </a:solidFill>
+                <a:latin typeface="Aptos Display"/>
+              </a:defRPr>
+            </a:pPr>
+            <a:r>
+              <a:t>Qu? aporta esta arquitectura</a:t>
+            </a:r>
+          </a:p>
+        </p:txBody>
+      </p:sp>
+      <p:sp>
+        <p:nvSpPr>
+          <p:cNvPr id="12" name="TextBox 11"/>
+          <p:cNvSpPr txBox="1"/>
+          <p:nvPr/>
+        </p:nvSpPr>
+        <p:spPr>
+          <a:xfrm>
+            <a:off x="731520" y="3931920"/>
+            <a:ext cx="10972800" cy="1554480"/>
+          </a:xfrm>
+          <a:prstGeom prst="rect">
+            <a:avLst/>
+          </a:prstGeom>
+          <a:noFill/>
+        </p:spPr>
+        <p:txBody>
+          <a:bodyPr wrap="square" lIns="0" rIns="0" tIns="0" anchor="t">
+            <a:spAutoFit/>
+          </a:bodyPr>
+          <a:lstStyle/>
+          <a:p>
+            <a:pPr>
+              <a:spcAft>
+                <a:spcPts val="800"/>
+              </a:spcAft>
+              <a:defRPr sz="1600">
+                <a:solidFill>
+                  <a:srgbClr val="1E293B"/>
+                </a:solidFill>
+                <a:latin typeface="Aptos"/>
+              </a:defRPr>
+            </a:pPr>
+            <a:r>
+              <a:t>Eureka facilita descubrimiento y registro de servicios.</a:t>
+            </a:r>
+          </a:p>
+          <a:p>
+            <a:pPr>
+              <a:spcAft>
+                <a:spcPts val="800"/>
+              </a:spcAft>
+              <a:defRPr sz="1600">
+                <a:solidFill>
+                  <a:srgbClr val="1E293B"/>
+                </a:solidFill>
+                <a:latin typeface="Aptos"/>
+              </a:defRPr>
+            </a:pPr>
+            <a:r>
+              <a:t>El BFF protege al frontend de cambios internos.</a:t>
+            </a:r>
+          </a:p>
+          <a:p>
+            <a:pPr>
+              <a:spcAft>
+                <a:spcPts val="800"/>
+              </a:spcAft>
+              <a:defRPr sz="1600">
+                <a:solidFill>
+                  <a:srgbClr val="1E293B"/>
+                </a:solidFill>
+                <a:latin typeface="Aptos"/>
+              </a:defRPr>
+            </a:pPr>
+            <a:r>
+              <a:t>Los microservicios de dominio pueden evolucionar por separado.</a:t>
+            </a:r>
+          </a:p>
+          <a:p>
+            <a:pPr>
+              <a:spcAft>
+                <a:spcPts val="800"/>
+              </a:spcAft>
+              <a:defRPr sz="1600">
+                <a:solidFill>
+                  <a:srgbClr val="1E293B"/>
+                </a:solidFill>
+                <a:latin typeface="Aptos"/>
+              </a:defRPr>
+            </a:pPr>
+            <a:r>
+              <a:t>La plataforma queda lista para crecer sin reescritura total.</a:t>
+            </a:r>
+          </a:p>
+        </p:txBody>
+      </p:sp>
+      <p:sp>
+        <p:nvSpPr>
+          <p:cNvPr id="13" name="TextBox 12"/>
+          <p:cNvSpPr txBox="1"/>
+          <p:nvPr/>
+        </p:nvSpPr>
+        <p:spPr>
+          <a:xfrm>
+            <a:off x="502920" y="6400800"/>
+            <a:ext cx="10972800" cy="228600"/>
+          </a:xfrm>
+          <a:prstGeom prst="rect">
+            <a:avLst/>
+          </a:prstGeom>
+          <a:noFill/>
+        </p:spPr>
+        <p:txBody>
+          <a:bodyPr wrap="none">
+            <a:spAutoFit/>
+          </a:bodyPr>
+          <a:lstStyle/>
+          <a:p>
+            <a:pPr algn="r">
+              <a:defRPr sz="900">
+                <a:solidFill>
+                  <a:srgbClr val="64748B"/>
+                </a:solidFill>
+              </a:defRPr>
+            </a:pPr>
+            <a:r>
+              <a:t>RedNorte | Parcial 3</a:t>
             </a:r>
           </a:p>
         </p:txBody>
@@ -3309,6 +4474,14 @@
 <file path=ppt/slides/slide4.xml><?xml version="1.0" encoding="utf-8"?>
 <p:sld xmlns:a="http://schemas.openxmlformats.org/drawingml/2006/main" xmlns:p="http://schemas.openxmlformats.org/presentationml/2006/main" xmlns:r="http://schemas.openxmlformats.org/officeDocument/2006/relationships">
   <p:cSld>
+    <p:bg>
+      <p:bgPr>
+        <a:solidFill>
+          <a:srgbClr val="FFFFFF"/>
+        </a:solidFill>
+        <a:effectLst/>
+      </p:bgPr>
+    </p:bg>
     <p:spTree>
       <p:nvGrpSpPr>
         <p:cNvPr id="1" name=""/>
@@ -3318,62 +4491,362 @@
       <p:grpSpPr/>
       <p:sp>
         <p:nvSpPr>
-          <p:cNvPr id="2" name="Title 1"/>
-          <p:cNvSpPr>
-            <a:spLocks noGrp="1"/>
-          </p:cNvSpPr>
-          <p:nvPr>
-            <p:ph type="title"/>
-          </p:nvPr>
-        </p:nvSpPr>
-        <p:spPr/>
-        <p:txBody>
-          <a:bodyPr/>
-          <a:lstStyle/>
-          <a:p>
-            <a:r>
-              <a:t>3. Pruebas Unitarias</a:t>
-            </a:r>
-          </a:p>
-        </p:txBody>
-      </p:sp>
-      <p:sp>
-        <p:nvSpPr>
-          <p:cNvPr id="3" name="Content Placeholder 2"/>
-          <p:cNvSpPr>
-            <a:spLocks noGrp="1"/>
-          </p:cNvSpPr>
-          <p:nvPr>
-            <p:ph idx="1"/>
-          </p:nvPr>
-        </p:nvSpPr>
-        <p:spPr/>
-        <p:txBody>
-          <a:bodyPr/>
-          <a:lstStyle/>
-          <a:p>
-            <a:r>
-              <a:t>ms-pacientes: 94.20%</a:t>
-            </a:r>
-          </a:p>
-          <a:p>
-            <a:r>
-              <a:t>ms-citas: 94.63%</a:t>
-            </a:r>
-          </a:p>
-          <a:p>
-            <a:r>
-              <a:t>bff: 63.27%</a:t>
-            </a:r>
-          </a:p>
-          <a:p>
-            <a:r>
-              <a:t>Promedio backend: 83.70%</a:t>
-            </a:r>
-          </a:p>
-          <a:p>
-            <a:r>
-              <a:t>Evidencia: entregables/informe_pruebas_unitarias.txt</a:t>
+          <p:cNvPr id="2" name="Rectangle 1"/>
+          <p:cNvSpPr/>
+          <p:nvPr/>
+        </p:nvSpPr>
+        <p:spPr>
+          <a:xfrm>
+            <a:off x="0" y="0"/>
+            <a:ext cx="12191695" cy="685800"/>
+          </a:xfrm>
+          <a:prstGeom prst="rect">
+            <a:avLst/>
+          </a:prstGeom>
+          <a:solidFill>
+            <a:srgbClr val="112A4A"/>
+          </a:solidFill>
+          <a:ln>
+            <a:noFill/>
+          </a:ln>
+        </p:spPr>
+        <p:style>
+          <a:lnRef idx="1">
+            <a:schemeClr val="accent1"/>
+          </a:lnRef>
+          <a:fillRef idx="3">
+            <a:schemeClr val="accent1"/>
+          </a:fillRef>
+          <a:effectRef idx="2">
+            <a:schemeClr val="accent1"/>
+          </a:effectRef>
+          <a:fontRef idx="minor">
+            <a:schemeClr val="lt1"/>
+          </a:fontRef>
+        </p:style>
+        <p:txBody>
+          <a:bodyPr rtlCol="0" anchor="ctr"/>
+          <a:lstStyle/>
+          <a:p>
+            <a:pPr algn="ctr"/>
+          </a:p>
+        </p:txBody>
+      </p:sp>
+      <p:sp>
+        <p:nvSpPr>
+          <p:cNvPr id="3" name="TextBox 2"/>
+          <p:cNvSpPr txBox="1"/>
+          <p:nvPr/>
+        </p:nvSpPr>
+        <p:spPr>
+          <a:xfrm>
+            <a:off x="502920" y="109728"/>
+            <a:ext cx="9875520" cy="411480"/>
+          </a:xfrm>
+          <a:prstGeom prst="rect">
+            <a:avLst/>
+          </a:prstGeom>
+          <a:noFill/>
+        </p:spPr>
+        <p:txBody>
+          <a:bodyPr wrap="none">
+            <a:spAutoFit/>
+          </a:bodyPr>
+          <a:lstStyle/>
+          <a:p>
+            <a:r>
+              <a:rPr sz="2400" b="1">
+                <a:solidFill>
+                  <a:srgbClr val="FFFFFF"/>
+                </a:solidFill>
+                <a:latin typeface="Aptos Display"/>
+              </a:rPr>
+              <a:t>Flujo funcional demostrado en la interfaz</a:t>
+            </a:r>
+          </a:p>
+          <a:p>
+            <a:pPr algn="r">
+              <a:defRPr sz="1050">
+                <a:solidFill>
+                  <a:srgbClr val="D7E2F0"/>
+                </a:solidFill>
+                <a:latin typeface="Aptos"/>
+              </a:defRPr>
+            </a:pPr>
+            <a:r>
+              <a:t>Lo que se muestra en el video</a:t>
+            </a:r>
+          </a:p>
+        </p:txBody>
+      </p:sp>
+      <p:sp>
+        <p:nvSpPr>
+          <p:cNvPr id="4" name="TextBox 3"/>
+          <p:cNvSpPr txBox="1"/>
+          <p:nvPr/>
+        </p:nvSpPr>
+        <p:spPr>
+          <a:xfrm>
+            <a:off x="731520" y="1097280"/>
+            <a:ext cx="5486400" cy="384048"/>
+          </a:xfrm>
+          <a:prstGeom prst="rect">
+            <a:avLst/>
+          </a:prstGeom>
+          <a:noFill/>
+        </p:spPr>
+        <p:txBody>
+          <a:bodyPr wrap="none">
+            <a:spAutoFit/>
+          </a:bodyPr>
+          <a:lstStyle/>
+          <a:p>
+            <a:pPr>
+              <a:defRPr sz="2000" b="1">
+                <a:solidFill>
+                  <a:srgbClr val="F2B02D"/>
+                </a:solidFill>
+                <a:latin typeface="Aptos Display"/>
+              </a:defRPr>
+            </a:pPr>
+            <a:r>
+              <a:t>Escenario de demo</a:t>
+            </a:r>
+          </a:p>
+        </p:txBody>
+      </p:sp>
+      <p:sp>
+        <p:nvSpPr>
+          <p:cNvPr id="5" name="TextBox 4"/>
+          <p:cNvSpPr txBox="1"/>
+          <p:nvPr/>
+        </p:nvSpPr>
+        <p:spPr>
+          <a:xfrm>
+            <a:off x="731520" y="1554480"/>
+            <a:ext cx="5486400" cy="4663440"/>
+          </a:xfrm>
+          <a:prstGeom prst="rect">
+            <a:avLst/>
+          </a:prstGeom>
+          <a:noFill/>
+        </p:spPr>
+        <p:txBody>
+          <a:bodyPr wrap="square" lIns="0" rIns="0" tIns="0" anchor="t">
+            <a:spAutoFit/>
+          </a:bodyPr>
+          <a:lstStyle/>
+          <a:p>
+            <a:pPr>
+              <a:spcAft>
+                <a:spcPts val="800"/>
+              </a:spcAft>
+              <a:defRPr sz="1600">
+                <a:solidFill>
+                  <a:srgbClr val="1E293B"/>
+                </a:solidFill>
+                <a:latin typeface="Aptos"/>
+              </a:defRPr>
+            </a:pPr>
+            <a:r>
+              <a:t>Alta de paciente.</a:t>
+            </a:r>
+          </a:p>
+          <a:p>
+            <a:pPr>
+              <a:spcAft>
+                <a:spcPts val="800"/>
+              </a:spcAft>
+              <a:defRPr sz="1600">
+                <a:solidFill>
+                  <a:srgbClr val="1E293B"/>
+                </a:solidFill>
+                <a:latin typeface="Aptos"/>
+              </a:defRPr>
+            </a:pPr>
+            <a:r>
+              <a:t>B?squeda y actualizaci?n de datos.</a:t>
+            </a:r>
+          </a:p>
+          <a:p>
+            <a:pPr>
+              <a:spcAft>
+                <a:spcPts val="800"/>
+              </a:spcAft>
+              <a:defRPr sz="1600">
+                <a:solidFill>
+                  <a:srgbClr val="1E293B"/>
+                </a:solidFill>
+                <a:latin typeface="Aptos"/>
+              </a:defRPr>
+            </a:pPr>
+            <a:r>
+              <a:t>Alta de cita asociada.</a:t>
+            </a:r>
+          </a:p>
+          <a:p>
+            <a:pPr>
+              <a:spcAft>
+                <a:spcPts val="800"/>
+              </a:spcAft>
+              <a:defRPr sz="1600">
+                <a:solidFill>
+                  <a:srgbClr val="1E293B"/>
+                </a:solidFill>
+                <a:latin typeface="Aptos"/>
+              </a:defRPr>
+            </a:pPr>
+            <a:r>
+              <a:t>Edici?n y eliminaci?n cuando corresponde.</a:t>
+            </a:r>
+          </a:p>
+        </p:txBody>
+      </p:sp>
+      <p:sp>
+        <p:nvSpPr>
+          <p:cNvPr id="6" name="Rounded Rectangle 5"/>
+          <p:cNvSpPr/>
+          <p:nvPr/>
+        </p:nvSpPr>
+        <p:spPr>
+          <a:xfrm>
+            <a:off x="6400800" y="1143000"/>
+            <a:ext cx="4937760" cy="4800600"/>
+          </a:xfrm>
+          <a:prstGeom prst="roundRect">
+            <a:avLst/>
+          </a:prstGeom>
+          <a:solidFill>
+            <a:srgbClr val="E7F8F7"/>
+          </a:solidFill>
+          <a:ln>
+            <a:solidFill>
+              <a:srgbClr val="C3DFDD"/>
+            </a:solidFill>
+          </a:ln>
+        </p:spPr>
+        <p:style>
+          <a:lnRef idx="1">
+            <a:schemeClr val="accent1"/>
+          </a:lnRef>
+          <a:fillRef idx="3">
+            <a:schemeClr val="accent1"/>
+          </a:fillRef>
+          <a:effectRef idx="2">
+            <a:schemeClr val="accent1"/>
+          </a:effectRef>
+          <a:fontRef idx="minor">
+            <a:schemeClr val="lt1"/>
+          </a:fontRef>
+        </p:style>
+        <p:txBody>
+          <a:bodyPr rtlCol="0" anchor="ctr" lIns="228600" tIns="164592"/>
+          <a:lstStyle/>
+          <a:p>
+            <a:pPr algn="ctr">
+              <a:defRPr sz="1800" b="1">
+                <a:solidFill>
+                  <a:srgbClr val="112A4A"/>
+                </a:solidFill>
+              </a:defRPr>
+            </a:pPr>
+            <a:r>
+              <a:t>Mensaje para narrar</a:t>
+            </a:r>
+          </a:p>
+          <a:p>
+            <a:pPr>
+              <a:spcAft>
+                <a:spcPts val="800"/>
+              </a:spcAft>
+              <a:defRPr sz="1600">
+                <a:solidFill>
+                  <a:srgbClr val="1E293B"/>
+                </a:solidFill>
+              </a:defRPr>
+            </a:pPr>
+            <a:r>
+              <a:t>Registrar un paciente toma pocos pasos.</a:t>
+            </a:r>
+          </a:p>
+          <a:p>
+            <a:pPr>
+              <a:spcAft>
+                <a:spcPts val="800"/>
+              </a:spcAft>
+              <a:defRPr sz="1600">
+                <a:solidFill>
+                  <a:srgbClr val="1E293B"/>
+                </a:solidFill>
+              </a:defRPr>
+            </a:pPr>
+            <a:r>
+              <a:t>La informaci?n se puede buscar y corregir en segundos.</a:t>
+            </a:r>
+          </a:p>
+          <a:p>
+            <a:pPr>
+              <a:spcAft>
+                <a:spcPts val="800"/>
+              </a:spcAft>
+              <a:defRPr sz="1600">
+                <a:solidFill>
+                  <a:srgbClr val="1E293B"/>
+                </a:solidFill>
+              </a:defRPr>
+            </a:pPr>
+            <a:r>
+              <a:t>La cita queda vinculada al paciente de forma clara.</a:t>
+            </a:r>
+          </a:p>
+          <a:p>
+            <a:pPr>
+              <a:spcAft>
+                <a:spcPts val="800"/>
+              </a:spcAft>
+              <a:defRPr sz="1600">
+                <a:solidFill>
+                  <a:srgbClr val="1E293B"/>
+                </a:solidFill>
+              </a:defRPr>
+            </a:pPr>
+            <a:r>
+              <a:t>Esto refleja un flujo cl?nico simple, r?pido y trazable.</a:t>
+            </a:r>
+          </a:p>
+        </p:txBody>
+      </p:sp>
+      <p:sp>
+        <p:nvSpPr>
+          <p:cNvPr id="7" name="TextBox 6"/>
+          <p:cNvSpPr txBox="1"/>
+          <p:nvPr/>
+        </p:nvSpPr>
+        <p:spPr>
+          <a:xfrm>
+            <a:off x="502920" y="6400800"/>
+            <a:ext cx="10972800" cy="228600"/>
+          </a:xfrm>
+          <a:prstGeom prst="rect">
+            <a:avLst/>
+          </a:prstGeom>
+          <a:noFill/>
+        </p:spPr>
+        <p:txBody>
+          <a:bodyPr wrap="none">
+            <a:spAutoFit/>
+          </a:bodyPr>
+          <a:lstStyle/>
+          <a:p>
+            <a:pPr algn="r">
+              <a:defRPr sz="900">
+                <a:solidFill>
+                  <a:srgbClr val="64748B"/>
+                </a:solidFill>
+              </a:defRPr>
+            </a:pPr>
+            <a:r>
+              <a:t>RedNorte | Parcial 3</a:t>
             </a:r>
           </a:p>
         </p:txBody>
@@ -3389,6 +4862,14 @@
 <file path=ppt/slides/slide5.xml><?xml version="1.0" encoding="utf-8"?>
 <p:sld xmlns:a="http://schemas.openxmlformats.org/drawingml/2006/main" xmlns:p="http://schemas.openxmlformats.org/presentationml/2006/main" xmlns:r="http://schemas.openxmlformats.org/officeDocument/2006/relationships">
   <p:cSld>
+    <p:bg>
+      <p:bgPr>
+        <a:solidFill>
+          <a:srgbClr val="FFFFFF"/>
+        </a:solidFill>
+        <a:effectLst/>
+      </p:bgPr>
+    </p:bg>
     <p:spTree>
       <p:nvGrpSpPr>
         <p:cNvPr id="1" name=""/>
@@ -3398,62 +4879,394 @@
       <p:grpSpPr/>
       <p:sp>
         <p:nvSpPr>
-          <p:cNvPr id="2" name="Title 1"/>
-          <p:cNvSpPr>
-            <a:spLocks noGrp="1"/>
-          </p:cNvSpPr>
-          <p:nvPr>
-            <p:ph type="title"/>
-          </p:nvPr>
-        </p:nvSpPr>
-        <p:spPr/>
-        <p:txBody>
-          <a:bodyPr/>
-          <a:lstStyle/>
-          <a:p>
-            <a:r>
-              <a:t>4. Integracion (Ejecucion)</a:t>
-            </a:r>
-          </a:p>
-        </p:txBody>
-      </p:sp>
-      <p:sp>
-        <p:nvSpPr>
-          <p:cNvPr id="3" name="Content Placeholder 2"/>
-          <p:cNvSpPr>
-            <a:spLocks noGrp="1"/>
-          </p:cNvSpPr>
-          <p:nvPr>
-            <p:ph idx="1"/>
-          </p:nvPr>
-        </p:nvSpPr>
-        <p:spPr/>
-        <p:txBody>
-          <a:bodyPr/>
-          <a:lstStyle/>
-          <a:p>
-            <a:r>
-              <a:t>INT-00 disponibilidad de servicios: PASS</a:t>
-            </a:r>
-          </a:p>
-          <a:p>
-            <a:r>
-              <a:t>INT-01 alta paciente via BFF: PASS</a:t>
-            </a:r>
-          </a:p>
-          <a:p>
-            <a:r>
-              <a:t>INT-02 alta cita asociada: PASS</a:t>
-            </a:r>
-          </a:p>
-          <a:p>
-            <a:r>
-              <a:t>INT-03 no happy path recurso inexistente: PASS</a:t>
-            </a:r>
-          </a:p>
-          <a:p>
-            <a:r>
-              <a:t>Evidencia: entregables/INFORME_PRUEBAS_INTEGRACION_E2E.md</a:t>
+          <p:cNvPr id="2" name="Rectangle 1"/>
+          <p:cNvSpPr/>
+          <p:nvPr/>
+        </p:nvSpPr>
+        <p:spPr>
+          <a:xfrm>
+            <a:off x="0" y="0"/>
+            <a:ext cx="12191695" cy="685800"/>
+          </a:xfrm>
+          <a:prstGeom prst="rect">
+            <a:avLst/>
+          </a:prstGeom>
+          <a:solidFill>
+            <a:srgbClr val="112A4A"/>
+          </a:solidFill>
+          <a:ln>
+            <a:noFill/>
+          </a:ln>
+        </p:spPr>
+        <p:style>
+          <a:lnRef idx="1">
+            <a:schemeClr val="accent1"/>
+          </a:lnRef>
+          <a:fillRef idx="3">
+            <a:schemeClr val="accent1"/>
+          </a:fillRef>
+          <a:effectRef idx="2">
+            <a:schemeClr val="accent1"/>
+          </a:effectRef>
+          <a:fontRef idx="minor">
+            <a:schemeClr val="lt1"/>
+          </a:fontRef>
+        </p:style>
+        <p:txBody>
+          <a:bodyPr rtlCol="0" anchor="ctr"/>
+          <a:lstStyle/>
+          <a:p>
+            <a:pPr algn="ctr"/>
+          </a:p>
+        </p:txBody>
+      </p:sp>
+      <p:sp>
+        <p:nvSpPr>
+          <p:cNvPr id="3" name="TextBox 2"/>
+          <p:cNvSpPr txBox="1"/>
+          <p:nvPr/>
+        </p:nvSpPr>
+        <p:spPr>
+          <a:xfrm>
+            <a:off x="502920" y="109728"/>
+            <a:ext cx="9875520" cy="411480"/>
+          </a:xfrm>
+          <a:prstGeom prst="rect">
+            <a:avLst/>
+          </a:prstGeom>
+          <a:noFill/>
+        </p:spPr>
+        <p:txBody>
+          <a:bodyPr wrap="none">
+            <a:spAutoFit/>
+          </a:bodyPr>
+          <a:lstStyle/>
+          <a:p>
+            <a:r>
+              <a:rPr sz="2400" b="1">
+                <a:solidFill>
+                  <a:srgbClr val="FFFFFF"/>
+                </a:solidFill>
+                <a:latin typeface="Aptos Display"/>
+              </a:rPr>
+              <a:t>APIs y validaci?n con Postman</a:t>
+            </a:r>
+          </a:p>
+          <a:p>
+            <a:pPr algn="r">
+              <a:defRPr sz="1050">
+                <a:solidFill>
+                  <a:srgbClr val="D7E2F0"/>
+                </a:solidFill>
+                <a:latin typeface="Aptos"/>
+              </a:defRPr>
+            </a:pPr>
+            <a:r>
+              <a:t>Evidencia de funcionamiento del backend</a:t>
+            </a:r>
+          </a:p>
+        </p:txBody>
+      </p:sp>
+      <p:sp>
+        <p:nvSpPr>
+          <p:cNvPr id="4" name="TextBox 3"/>
+          <p:cNvSpPr txBox="1"/>
+          <p:nvPr/>
+        </p:nvSpPr>
+        <p:spPr>
+          <a:xfrm>
+            <a:off x="731520" y="1097280"/>
+            <a:ext cx="5303520" cy="384048"/>
+          </a:xfrm>
+          <a:prstGeom prst="rect">
+            <a:avLst/>
+          </a:prstGeom>
+          <a:noFill/>
+        </p:spPr>
+        <p:txBody>
+          <a:bodyPr wrap="none">
+            <a:spAutoFit/>
+          </a:bodyPr>
+          <a:lstStyle/>
+          <a:p>
+            <a:pPr>
+              <a:defRPr sz="2000" b="1">
+                <a:solidFill>
+                  <a:srgbClr val="147E7C"/>
+                </a:solidFill>
+                <a:latin typeface="Aptos Display"/>
+              </a:defRPr>
+            </a:pPr>
+            <a:r>
+              <a:t>Requests que conviene mostrar</a:t>
+            </a:r>
+          </a:p>
+        </p:txBody>
+      </p:sp>
+      <p:sp>
+        <p:nvSpPr>
+          <p:cNvPr id="5" name="TextBox 4"/>
+          <p:cNvSpPr txBox="1"/>
+          <p:nvPr/>
+        </p:nvSpPr>
+        <p:spPr>
+          <a:xfrm>
+            <a:off x="731520" y="1554480"/>
+            <a:ext cx="5303520" cy="4663440"/>
+          </a:xfrm>
+          <a:prstGeom prst="rect">
+            <a:avLst/>
+          </a:prstGeom>
+          <a:noFill/>
+        </p:spPr>
+        <p:txBody>
+          <a:bodyPr wrap="square" lIns="0" rIns="0" tIns="0" anchor="t">
+            <a:spAutoFit/>
+          </a:bodyPr>
+          <a:lstStyle/>
+          <a:p>
+            <a:pPr>
+              <a:spcAft>
+                <a:spcPts val="800"/>
+              </a:spcAft>
+              <a:defRPr sz="1600">
+                <a:solidFill>
+                  <a:srgbClr val="1E293B"/>
+                </a:solidFill>
+                <a:latin typeface="Aptos"/>
+              </a:defRPr>
+            </a:pPr>
+            <a:r>
+              <a:t>GET /api/pacientes</a:t>
+            </a:r>
+          </a:p>
+          <a:p>
+            <a:pPr>
+              <a:spcAft>
+                <a:spcPts val="800"/>
+              </a:spcAft>
+              <a:defRPr sz="1600">
+                <a:solidFill>
+                  <a:srgbClr val="1E293B"/>
+                </a:solidFill>
+                <a:latin typeface="Aptos"/>
+              </a:defRPr>
+            </a:pPr>
+            <a:r>
+              <a:t>POST /api/pacientes</a:t>
+            </a:r>
+          </a:p>
+          <a:p>
+            <a:pPr>
+              <a:spcAft>
+                <a:spcPts val="800"/>
+              </a:spcAft>
+              <a:defRPr sz="1600">
+                <a:solidFill>
+                  <a:srgbClr val="1E293B"/>
+                </a:solidFill>
+                <a:latin typeface="Aptos"/>
+              </a:defRPr>
+            </a:pPr>
+            <a:r>
+              <a:t>PUT /api/pacientes/{id}</a:t>
+            </a:r>
+          </a:p>
+          <a:p>
+            <a:pPr>
+              <a:spcAft>
+                <a:spcPts val="800"/>
+              </a:spcAft>
+              <a:defRPr sz="1600">
+                <a:solidFill>
+                  <a:srgbClr val="1E293B"/>
+                </a:solidFill>
+                <a:latin typeface="Aptos"/>
+              </a:defRPr>
+            </a:pPr>
+            <a:r>
+              <a:t>GET /api/citas</a:t>
+            </a:r>
+          </a:p>
+          <a:p>
+            <a:pPr>
+              <a:spcAft>
+                <a:spcPts val="800"/>
+              </a:spcAft>
+              <a:defRPr sz="1600">
+                <a:solidFill>
+                  <a:srgbClr val="1E293B"/>
+                </a:solidFill>
+                <a:latin typeface="Aptos"/>
+              </a:defRPr>
+            </a:pPr>
+            <a:r>
+              <a:t>POST /api/citas</a:t>
+            </a:r>
+          </a:p>
+          <a:p>
+            <a:pPr>
+              <a:spcAft>
+                <a:spcPts val="800"/>
+              </a:spcAft>
+              <a:defRPr sz="1600">
+                <a:solidFill>
+                  <a:srgbClr val="1E293B"/>
+                </a:solidFill>
+                <a:latin typeface="Aptos"/>
+              </a:defRPr>
+            </a:pPr>
+            <a:r>
+              <a:t>PUT /api/citas/{id}</a:t>
+            </a:r>
+          </a:p>
+        </p:txBody>
+      </p:sp>
+      <p:sp>
+        <p:nvSpPr>
+          <p:cNvPr id="6" name="Rounded Rectangle 5"/>
+          <p:cNvSpPr/>
+          <p:nvPr/>
+        </p:nvSpPr>
+        <p:spPr>
+          <a:xfrm>
+            <a:off x="6309360" y="1143000"/>
+            <a:ext cx="5074920" cy="4800600"/>
+          </a:xfrm>
+          <a:prstGeom prst="roundRect">
+            <a:avLst/>
+          </a:prstGeom>
+          <a:solidFill>
+            <a:srgbClr val="F5F8FC"/>
+          </a:solidFill>
+          <a:ln>
+            <a:solidFill>
+              <a:srgbClr val="DCE6F2"/>
+            </a:solidFill>
+          </a:ln>
+        </p:spPr>
+        <p:style>
+          <a:lnRef idx="1">
+            <a:schemeClr val="accent1"/>
+          </a:lnRef>
+          <a:fillRef idx="3">
+            <a:schemeClr val="accent1"/>
+          </a:fillRef>
+          <a:effectRef idx="2">
+            <a:schemeClr val="accent1"/>
+          </a:effectRef>
+          <a:fontRef idx="minor">
+            <a:schemeClr val="lt1"/>
+          </a:fontRef>
+        </p:style>
+        <p:txBody>
+          <a:bodyPr rtlCol="0" anchor="ctr" lIns="228600" tIns="164592"/>
+          <a:lstStyle/>
+          <a:p>
+            <a:pPr algn="ctr">
+              <a:defRPr sz="1800" b="1">
+                <a:solidFill>
+                  <a:srgbClr val="112A4A"/>
+                </a:solidFill>
+              </a:defRPr>
+            </a:pPr>
+            <a:r>
+              <a:t>Qu? validar en la demo</a:t>
+            </a:r>
+          </a:p>
+          <a:p>
+            <a:pPr>
+              <a:spcAft>
+                <a:spcPts val="800"/>
+              </a:spcAft>
+              <a:defRPr sz="1600">
+                <a:solidFill>
+                  <a:srgbClr val="1E293B"/>
+                </a:solidFill>
+              </a:defRPr>
+            </a:pPr>
+            <a:r>
+              <a:t>C?digo HTTP correcto en cada request.</a:t>
+            </a:r>
+          </a:p>
+          <a:p>
+            <a:pPr>
+              <a:spcAft>
+                <a:spcPts val="800"/>
+              </a:spcAft>
+              <a:defRPr sz="1600">
+                <a:solidFill>
+                  <a:srgbClr val="1E293B"/>
+                </a:solidFill>
+              </a:defRPr>
+            </a:pPr>
+            <a:r>
+              <a:t>Respuesta JSON coherente con la operaci?n.</a:t>
+            </a:r>
+          </a:p>
+          <a:p>
+            <a:pPr>
+              <a:spcAft>
+                <a:spcPts val="800"/>
+              </a:spcAft>
+              <a:defRPr sz="1600">
+                <a:solidFill>
+                  <a:srgbClr val="1E293B"/>
+                </a:solidFill>
+              </a:defRPr>
+            </a:pPr>
+            <a:r>
+              <a:t>Relaci?n citas por paciente.</a:t>
+            </a:r>
+          </a:p>
+          <a:p>
+            <a:pPr>
+              <a:spcAft>
+                <a:spcPts val="800"/>
+              </a:spcAft>
+              <a:defRPr sz="1600">
+                <a:solidFill>
+                  <a:srgbClr val="1E293B"/>
+                </a:solidFill>
+              </a:defRPr>
+            </a:pPr>
+            <a:r>
+              <a:t>Backend aislado del frontend para validaci?n t?cnica.</a:t>
+            </a:r>
+          </a:p>
+        </p:txBody>
+      </p:sp>
+      <p:sp>
+        <p:nvSpPr>
+          <p:cNvPr id="7" name="TextBox 6"/>
+          <p:cNvSpPr txBox="1"/>
+          <p:nvPr/>
+        </p:nvSpPr>
+        <p:spPr>
+          <a:xfrm>
+            <a:off x="502920" y="6400800"/>
+            <a:ext cx="10972800" cy="228600"/>
+          </a:xfrm>
+          <a:prstGeom prst="rect">
+            <a:avLst/>
+          </a:prstGeom>
+          <a:noFill/>
+        </p:spPr>
+        <p:txBody>
+          <a:bodyPr wrap="none">
+            <a:spAutoFit/>
+          </a:bodyPr>
+          <a:lstStyle/>
+          <a:p>
+            <a:pPr algn="r">
+              <a:defRPr sz="900">
+                <a:solidFill>
+                  <a:srgbClr val="64748B"/>
+                </a:solidFill>
+              </a:defRPr>
+            </a:pPr>
+            <a:r>
+              <a:t>RedNorte | Parcial 3</a:t>
             </a:r>
           </a:p>
         </p:txBody>
@@ -3469,6 +5282,14 @@
 <file path=ppt/slides/slide6.xml><?xml version="1.0" encoding="utf-8"?>
 <p:sld xmlns:a="http://schemas.openxmlformats.org/drawingml/2006/main" xmlns:p="http://schemas.openxmlformats.org/presentationml/2006/main" xmlns:r="http://schemas.openxmlformats.org/officeDocument/2006/relationships">
   <p:cSld>
+    <p:bg>
+      <p:bgPr>
+        <a:solidFill>
+          <a:srgbClr val="FFFFFF"/>
+        </a:solidFill>
+        <a:effectLst/>
+      </p:bgPr>
+    </p:bg>
     <p:spTree>
       <p:nvGrpSpPr>
         <p:cNvPr id="1" name=""/>
@@ -3478,57 +5299,452 @@
       <p:grpSpPr/>
       <p:sp>
         <p:nvSpPr>
-          <p:cNvPr id="2" name="Title 1"/>
-          <p:cNvSpPr>
-            <a:spLocks noGrp="1"/>
-          </p:cNvSpPr>
-          <p:nvPr>
-            <p:ph type="title"/>
-          </p:nvPr>
-        </p:nvSpPr>
-        <p:spPr/>
-        <p:txBody>
-          <a:bodyPr/>
-          <a:lstStyle/>
-          <a:p>
-            <a:r>
-              <a:t>5. End-to-End UI (Playwright)</a:t>
-            </a:r>
-          </a:p>
-        </p:txBody>
-      </p:sp>
-      <p:sp>
-        <p:nvSpPr>
-          <p:cNvPr id="3" name="Content Placeholder 2"/>
-          <p:cNvSpPr>
-            <a:spLocks noGrp="1"/>
-          </p:cNvSpPr>
-          <p:nvPr>
-            <p:ph idx="1"/>
-          </p:nvPr>
-        </p:nvSpPr>
-        <p:spPr/>
-        <p:txBody>
-          <a:bodyPr/>
-          <a:lstStyle/>
-          <a:p>
-            <a:r>
-              <a:t>Caso E2E-UI-01 alta paciente + cita: PASS</a:t>
-            </a:r>
-          </a:p>
-          <a:p>
-            <a:r>
-              <a:t>Caso E2E-UI-02 validacion no happy path: PASS</a:t>
-            </a:r>
-          </a:p>
-          <a:p>
-            <a:r>
-              <a:t>Comando: npm run test:e2e</a:t>
-            </a:r>
-          </a:p>
-          <a:p>
-            <a:r>
-              <a:t>Evidencia: rednorte-frontend/playwright-report/index.html</a:t>
+          <p:cNvPr id="2" name="Rectangle 1"/>
+          <p:cNvSpPr/>
+          <p:nvPr/>
+        </p:nvSpPr>
+        <p:spPr>
+          <a:xfrm>
+            <a:off x="0" y="0"/>
+            <a:ext cx="12191695" cy="685800"/>
+          </a:xfrm>
+          <a:prstGeom prst="rect">
+            <a:avLst/>
+          </a:prstGeom>
+          <a:solidFill>
+            <a:srgbClr val="112A4A"/>
+          </a:solidFill>
+          <a:ln>
+            <a:noFill/>
+          </a:ln>
+        </p:spPr>
+        <p:style>
+          <a:lnRef idx="1">
+            <a:schemeClr val="accent1"/>
+          </a:lnRef>
+          <a:fillRef idx="3">
+            <a:schemeClr val="accent1"/>
+          </a:fillRef>
+          <a:effectRef idx="2">
+            <a:schemeClr val="accent1"/>
+          </a:effectRef>
+          <a:fontRef idx="minor">
+            <a:schemeClr val="lt1"/>
+          </a:fontRef>
+        </p:style>
+        <p:txBody>
+          <a:bodyPr rtlCol="0" anchor="ctr"/>
+          <a:lstStyle/>
+          <a:p>
+            <a:pPr algn="ctr"/>
+          </a:p>
+        </p:txBody>
+      </p:sp>
+      <p:sp>
+        <p:nvSpPr>
+          <p:cNvPr id="3" name="TextBox 2"/>
+          <p:cNvSpPr txBox="1"/>
+          <p:nvPr/>
+        </p:nvSpPr>
+        <p:spPr>
+          <a:xfrm>
+            <a:off x="502920" y="109728"/>
+            <a:ext cx="9875520" cy="411480"/>
+          </a:xfrm>
+          <a:prstGeom prst="rect">
+            <a:avLst/>
+          </a:prstGeom>
+          <a:noFill/>
+        </p:spPr>
+        <p:txBody>
+          <a:bodyPr wrap="none">
+            <a:spAutoFit/>
+          </a:bodyPr>
+          <a:lstStyle/>
+          <a:p>
+            <a:r>
+              <a:rPr sz="2400" b="1">
+                <a:solidFill>
+                  <a:srgbClr val="FFFFFF"/>
+                </a:solidFill>
+                <a:latin typeface="Aptos Display"/>
+              </a:rPr>
+              <a:t>Pruebas obligatorias y evidencia</a:t>
+            </a:r>
+          </a:p>
+          <a:p>
+            <a:pPr algn="r">
+              <a:defRPr sz="1050">
+                <a:solidFill>
+                  <a:srgbClr val="D7E2F0"/>
+                </a:solidFill>
+                <a:latin typeface="Aptos"/>
+              </a:defRPr>
+            </a:pPr>
+            <a:r>
+              <a:t>Lo que pide la pauta de evaluaci?n</a:t>
+            </a:r>
+          </a:p>
+        </p:txBody>
+      </p:sp>
+      <p:sp>
+        <p:nvSpPr>
+          <p:cNvPr id="4" name="Rounded Rectangle 3"/>
+          <p:cNvSpPr/>
+          <p:nvPr/>
+        </p:nvSpPr>
+        <p:spPr>
+          <a:xfrm>
+            <a:off x="731520" y="1371600"/>
+            <a:ext cx="3429000" cy="2926080"/>
+          </a:xfrm>
+          <a:prstGeom prst="roundRect">
+            <a:avLst/>
+          </a:prstGeom>
+          <a:solidFill>
+            <a:srgbClr val="FFFFFF"/>
+          </a:solidFill>
+          <a:ln>
+            <a:solidFill>
+              <a:srgbClr val="147E7C"/>
+            </a:solidFill>
+          </a:ln>
+        </p:spPr>
+        <p:style>
+          <a:lnRef idx="1">
+            <a:schemeClr val="accent1"/>
+          </a:lnRef>
+          <a:fillRef idx="3">
+            <a:schemeClr val="accent1"/>
+          </a:fillRef>
+          <a:effectRef idx="2">
+            <a:schemeClr val="accent1"/>
+          </a:effectRef>
+          <a:fontRef idx="minor">
+            <a:schemeClr val="lt1"/>
+          </a:fontRef>
+        </p:style>
+        <p:txBody>
+          <a:bodyPr rtlCol="0" anchor="ctr" lIns="137160" tIns="137160"/>
+          <a:lstStyle/>
+          <a:p>
+            <a:pPr algn="ctr">
+              <a:defRPr sz="1800" b="1">
+                <a:solidFill>
+                  <a:srgbClr val="147E7C"/>
+                </a:solidFill>
+              </a:defRPr>
+            </a:pPr>
+            <a:r>
+              <a:t>Unitarias</a:t>
+            </a:r>
+          </a:p>
+          <a:p>
+            <a:pPr>
+              <a:spcAft>
+                <a:spcPts val="800"/>
+              </a:spcAft>
+              <a:defRPr sz="1500">
+                <a:solidFill>
+                  <a:srgbClr val="1E293B"/>
+                </a:solidFill>
+              </a:defRPr>
+            </a:pPr>
+            <a:r>
+              <a:t>Validan l?gica aislada.</a:t>
+            </a:r>
+          </a:p>
+          <a:p>
+            <a:pPr>
+              <a:spcAft>
+                <a:spcPts val="800"/>
+              </a:spcAft>
+              <a:defRPr sz="1500">
+                <a:solidFill>
+                  <a:srgbClr val="1E293B"/>
+                </a:solidFill>
+              </a:defRPr>
+            </a:pPr>
+            <a:r>
+              <a:t>Cubren controladores y servicios.</a:t>
+            </a:r>
+          </a:p>
+        </p:txBody>
+      </p:sp>
+      <p:sp>
+        <p:nvSpPr>
+          <p:cNvPr id="5" name="Rounded Rectangle 4"/>
+          <p:cNvSpPr/>
+          <p:nvPr/>
+        </p:nvSpPr>
+        <p:spPr>
+          <a:xfrm>
+            <a:off x="4526280" y="1371600"/>
+            <a:ext cx="3429000" cy="2926080"/>
+          </a:xfrm>
+          <a:prstGeom prst="roundRect">
+            <a:avLst/>
+          </a:prstGeom>
+          <a:solidFill>
+            <a:srgbClr val="FFFFFF"/>
+          </a:solidFill>
+          <a:ln>
+            <a:solidFill>
+              <a:srgbClr val="F2B02D"/>
+            </a:solidFill>
+          </a:ln>
+        </p:spPr>
+        <p:style>
+          <a:lnRef idx="1">
+            <a:schemeClr val="accent1"/>
+          </a:lnRef>
+          <a:fillRef idx="3">
+            <a:schemeClr val="accent1"/>
+          </a:fillRef>
+          <a:effectRef idx="2">
+            <a:schemeClr val="accent1"/>
+          </a:effectRef>
+          <a:fontRef idx="minor">
+            <a:schemeClr val="lt1"/>
+          </a:fontRef>
+        </p:style>
+        <p:txBody>
+          <a:bodyPr rtlCol="0" anchor="ctr" lIns="137160" tIns="137160"/>
+          <a:lstStyle/>
+          <a:p>
+            <a:pPr algn="ctr">
+              <a:defRPr sz="1800" b="1">
+                <a:solidFill>
+                  <a:srgbClr val="F2B02D"/>
+                </a:solidFill>
+              </a:defRPr>
+            </a:pPr>
+            <a:r>
+              <a:t>Integraci?n</a:t>
+            </a:r>
+          </a:p>
+          <a:p>
+            <a:pPr>
+              <a:spcAft>
+                <a:spcPts val="800"/>
+              </a:spcAft>
+              <a:defRPr sz="1500">
+                <a:solidFill>
+                  <a:srgbClr val="1E293B"/>
+                </a:solidFill>
+              </a:defRPr>
+            </a:pPr>
+            <a:r>
+              <a:t>Validan comunicaci?n entre capas.</a:t>
+            </a:r>
+          </a:p>
+          <a:p>
+            <a:pPr>
+              <a:spcAft>
+                <a:spcPts val="800"/>
+              </a:spcAft>
+              <a:defRPr sz="1500">
+                <a:solidFill>
+                  <a:srgbClr val="1E293B"/>
+                </a:solidFill>
+              </a:defRPr>
+            </a:pPr>
+            <a:r>
+              <a:t>Comprueban flujo real entre servicios.</a:t>
+            </a:r>
+          </a:p>
+        </p:txBody>
+      </p:sp>
+      <p:sp>
+        <p:nvSpPr>
+          <p:cNvPr id="6" name="Rounded Rectangle 5"/>
+          <p:cNvSpPr/>
+          <p:nvPr/>
+        </p:nvSpPr>
+        <p:spPr>
+          <a:xfrm>
+            <a:off x="8321040" y="1371600"/>
+            <a:ext cx="3429000" cy="2926080"/>
+          </a:xfrm>
+          <a:prstGeom prst="roundRect">
+            <a:avLst/>
+          </a:prstGeom>
+          <a:solidFill>
+            <a:srgbClr val="FFFFFF"/>
+          </a:solidFill>
+          <a:ln>
+            <a:solidFill>
+              <a:srgbClr val="112A4A"/>
+            </a:solidFill>
+          </a:ln>
+        </p:spPr>
+        <p:style>
+          <a:lnRef idx="1">
+            <a:schemeClr val="accent1"/>
+          </a:lnRef>
+          <a:fillRef idx="3">
+            <a:schemeClr val="accent1"/>
+          </a:fillRef>
+          <a:effectRef idx="2">
+            <a:schemeClr val="accent1"/>
+          </a:effectRef>
+          <a:fontRef idx="minor">
+            <a:schemeClr val="lt1"/>
+          </a:fontRef>
+        </p:style>
+        <p:txBody>
+          <a:bodyPr rtlCol="0" anchor="ctr" lIns="137160" tIns="137160"/>
+          <a:lstStyle/>
+          <a:p>
+            <a:pPr algn="ctr">
+              <a:defRPr sz="1800" b="1">
+                <a:solidFill>
+                  <a:srgbClr val="112A4A"/>
+                </a:solidFill>
+              </a:defRPr>
+            </a:pPr>
+            <a:r>
+              <a:t>End to end</a:t>
+            </a:r>
+          </a:p>
+          <a:p>
+            <a:pPr>
+              <a:spcAft>
+                <a:spcPts val="800"/>
+              </a:spcAft>
+              <a:defRPr sz="1500">
+                <a:solidFill>
+                  <a:srgbClr val="1E293B"/>
+                </a:solidFill>
+              </a:defRPr>
+            </a:pPr>
+            <a:r>
+              <a:t>Validan la experiencia completa.</a:t>
+            </a:r>
+          </a:p>
+          <a:p>
+            <a:pPr>
+              <a:spcAft>
+                <a:spcPts val="800"/>
+              </a:spcAft>
+              <a:defRPr sz="1500">
+                <a:solidFill>
+                  <a:srgbClr val="1E293B"/>
+                </a:solidFill>
+              </a:defRPr>
+            </a:pPr>
+            <a:r>
+              <a:t>Cubren el recorrido desde UI hasta API.</a:t>
+            </a:r>
+          </a:p>
+        </p:txBody>
+      </p:sp>
+      <p:sp>
+        <p:nvSpPr>
+          <p:cNvPr id="7" name="TextBox 6"/>
+          <p:cNvSpPr txBox="1"/>
+          <p:nvPr/>
+        </p:nvSpPr>
+        <p:spPr>
+          <a:xfrm>
+            <a:off x="822960" y="4663440"/>
+            <a:ext cx="10515600" cy="384048"/>
+          </a:xfrm>
+          <a:prstGeom prst="rect">
+            <a:avLst/>
+          </a:prstGeom>
+          <a:noFill/>
+        </p:spPr>
+        <p:txBody>
+          <a:bodyPr wrap="none">
+            <a:spAutoFit/>
+          </a:bodyPr>
+          <a:lstStyle/>
+          <a:p>
+            <a:pPr>
+              <a:defRPr sz="2000" b="1">
+                <a:solidFill>
+                  <a:srgbClr val="147E7C"/>
+                </a:solidFill>
+                <a:latin typeface="Aptos Display"/>
+              </a:defRPr>
+            </a:pPr>
+            <a:r>
+              <a:t>Mensaje clave</a:t>
+            </a:r>
+          </a:p>
+        </p:txBody>
+      </p:sp>
+      <p:sp>
+        <p:nvSpPr>
+          <p:cNvPr id="8" name="TextBox 7"/>
+          <p:cNvSpPr txBox="1"/>
+          <p:nvPr/>
+        </p:nvSpPr>
+        <p:spPr>
+          <a:xfrm>
+            <a:off x="822960" y="5120640"/>
+            <a:ext cx="10515600" cy="822960"/>
+          </a:xfrm>
+          <a:prstGeom prst="rect">
+            <a:avLst/>
+          </a:prstGeom>
+          <a:noFill/>
+        </p:spPr>
+        <p:txBody>
+          <a:bodyPr wrap="square" lIns="0" rIns="0" tIns="0" anchor="t">
+            <a:spAutoFit/>
+          </a:bodyPr>
+          <a:lstStyle/>
+          <a:p>
+            <a:pPr>
+              <a:spcAft>
+                <a:spcPts val="800"/>
+              </a:spcAft>
+              <a:defRPr sz="1600">
+                <a:solidFill>
+                  <a:srgbClr val="1E293B"/>
+                </a:solidFill>
+                <a:latin typeface="Aptos"/>
+              </a:defRPr>
+            </a:pPr>
+            <a:r>
+              <a:t>Los casos se enfocan en procesos cr?ticos del negocio y dejan evidencia verificable.</a:t>
+            </a:r>
+          </a:p>
+        </p:txBody>
+      </p:sp>
+      <p:sp>
+        <p:nvSpPr>
+          <p:cNvPr id="9" name="TextBox 8"/>
+          <p:cNvSpPr txBox="1"/>
+          <p:nvPr/>
+        </p:nvSpPr>
+        <p:spPr>
+          <a:xfrm>
+            <a:off x="502920" y="6400800"/>
+            <a:ext cx="10972800" cy="228600"/>
+          </a:xfrm>
+          <a:prstGeom prst="rect">
+            <a:avLst/>
+          </a:prstGeom>
+          <a:noFill/>
+        </p:spPr>
+        <p:txBody>
+          <a:bodyPr wrap="none">
+            <a:spAutoFit/>
+          </a:bodyPr>
+          <a:lstStyle/>
+          <a:p>
+            <a:pPr algn="r">
+              <a:defRPr sz="900">
+                <a:solidFill>
+                  <a:srgbClr val="64748B"/>
+                </a:solidFill>
+              </a:defRPr>
+            </a:pPr>
+            <a:r>
+              <a:t>RedNorte | Parcial 3</a:t>
             </a:r>
           </a:p>
         </p:txBody>
@@ -3544,6 +5760,14 @@
 <file path=ppt/slides/slide7.xml><?xml version="1.0" encoding="utf-8"?>
 <p:sld xmlns:a="http://schemas.openxmlformats.org/drawingml/2006/main" xmlns:p="http://schemas.openxmlformats.org/presentationml/2006/main" xmlns:r="http://schemas.openxmlformats.org/officeDocument/2006/relationships">
   <p:cSld>
+    <p:bg>
+      <p:bgPr>
+        <a:solidFill>
+          <a:srgbClr val="FFFFFF"/>
+        </a:solidFill>
+        <a:effectLst/>
+      </p:bgPr>
+    </p:bg>
     <p:spTree>
       <p:nvGrpSpPr>
         <p:cNvPr id="1" name=""/>
@@ -3553,57 +5777,347 @@
       <p:grpSpPr/>
       <p:sp>
         <p:nvSpPr>
-          <p:cNvPr id="2" name="Title 1"/>
-          <p:cNvSpPr>
-            <a:spLocks noGrp="1"/>
-          </p:cNvSpPr>
-          <p:nvPr>
-            <p:ph type="title"/>
-          </p:nvPr>
-        </p:nvSpPr>
-        <p:spPr/>
-        <p:txBody>
-          <a:bodyPr/>
-          <a:lstStyle/>
-          <a:p>
-            <a:r>
-              <a:t>6. Hallazgos y Mejora</a:t>
-            </a:r>
-          </a:p>
-        </p:txBody>
-      </p:sp>
-      <p:sp>
-        <p:nvSpPr>
-          <p:cNvPr id="3" name="Content Placeholder 2"/>
-          <p:cNvSpPr>
-            <a:spLocks noGrp="1"/>
-          </p:cNvSpPr>
-          <p:nvPr>
-            <p:ph idx="1"/>
-          </p:nvPr>
-        </p:nvSpPr>
-        <p:spPr/>
-        <p:txBody>
-          <a:bodyPr/>
-          <a:lstStyle/>
-          <a:p>
-            <a:r>
-              <a:t>Hallazgo: bug en validador RUT con digito numerico</a:t>
-            </a:r>
-          </a:p>
-          <a:p>
-            <a:r>
-              <a:t>Causa: comparacion number vs string</a:t>
-            </a:r>
-          </a:p>
-          <a:p>
-            <a:r>
-              <a:t>Correccion: String(V) en validators.js</a:t>
-            </a:r>
-          </a:p>
-          <a:p>
-            <a:r>
-              <a:t>Resultado: validacion correcta de RUT y prueba E2E estable</a:t>
+          <p:cNvPr id="2" name="Rectangle 1"/>
+          <p:cNvSpPr/>
+          <p:nvPr/>
+        </p:nvSpPr>
+        <p:spPr>
+          <a:xfrm>
+            <a:off x="0" y="0"/>
+            <a:ext cx="12191695" cy="685800"/>
+          </a:xfrm>
+          <a:prstGeom prst="rect">
+            <a:avLst/>
+          </a:prstGeom>
+          <a:solidFill>
+            <a:srgbClr val="112A4A"/>
+          </a:solidFill>
+          <a:ln>
+            <a:noFill/>
+          </a:ln>
+        </p:spPr>
+        <p:style>
+          <a:lnRef idx="1">
+            <a:schemeClr val="accent1"/>
+          </a:lnRef>
+          <a:fillRef idx="3">
+            <a:schemeClr val="accent1"/>
+          </a:fillRef>
+          <a:effectRef idx="2">
+            <a:schemeClr val="accent1"/>
+          </a:effectRef>
+          <a:fontRef idx="minor">
+            <a:schemeClr val="lt1"/>
+          </a:fontRef>
+        </p:style>
+        <p:txBody>
+          <a:bodyPr rtlCol="0" anchor="ctr"/>
+          <a:lstStyle/>
+          <a:p>
+            <a:pPr algn="ctr"/>
+          </a:p>
+        </p:txBody>
+      </p:sp>
+      <p:sp>
+        <p:nvSpPr>
+          <p:cNvPr id="3" name="TextBox 2"/>
+          <p:cNvSpPr txBox="1"/>
+          <p:nvPr/>
+        </p:nvSpPr>
+        <p:spPr>
+          <a:xfrm>
+            <a:off x="502920" y="109728"/>
+            <a:ext cx="9875520" cy="411480"/>
+          </a:xfrm>
+          <a:prstGeom prst="rect">
+            <a:avLst/>
+          </a:prstGeom>
+          <a:noFill/>
+        </p:spPr>
+        <p:txBody>
+          <a:bodyPr wrap="none">
+            <a:spAutoFit/>
+          </a:bodyPr>
+          <a:lstStyle/>
+          <a:p>
+            <a:r>
+              <a:rPr sz="2400" b="1">
+                <a:solidFill>
+                  <a:srgbClr val="FFFFFF"/>
+                </a:solidFill>
+                <a:latin typeface="Aptos Display"/>
+              </a:rPr>
+              <a:t>Resultados, hallazgos y mejoras</a:t>
+            </a:r>
+          </a:p>
+          <a:p>
+            <a:pPr algn="r">
+              <a:defRPr sz="1050">
+                <a:solidFill>
+                  <a:srgbClr val="D7E2F0"/>
+                </a:solidFill>
+                <a:latin typeface="Aptos"/>
+              </a:defRPr>
+            </a:pPr>
+            <a:r>
+              <a:t>Qu? se aprendi? y qu? qued? resuelto</a:t>
+            </a:r>
+          </a:p>
+        </p:txBody>
+      </p:sp>
+      <p:sp>
+        <p:nvSpPr>
+          <p:cNvPr id="4" name="TextBox 3"/>
+          <p:cNvSpPr txBox="1"/>
+          <p:nvPr/>
+        </p:nvSpPr>
+        <p:spPr>
+          <a:xfrm>
+            <a:off x="731520" y="1097280"/>
+            <a:ext cx="5486400" cy="384048"/>
+          </a:xfrm>
+          <a:prstGeom prst="rect">
+            <a:avLst/>
+          </a:prstGeom>
+          <a:noFill/>
+        </p:spPr>
+        <p:txBody>
+          <a:bodyPr wrap="none">
+            <a:spAutoFit/>
+          </a:bodyPr>
+          <a:lstStyle/>
+          <a:p>
+            <a:pPr>
+              <a:defRPr sz="2000" b="1">
+                <a:solidFill>
+                  <a:srgbClr val="F2B02D"/>
+                </a:solidFill>
+                <a:latin typeface="Aptos Display"/>
+              </a:defRPr>
+            </a:pPr>
+            <a:r>
+              <a:t>Resultados</a:t>
+            </a:r>
+          </a:p>
+        </p:txBody>
+      </p:sp>
+      <p:sp>
+        <p:nvSpPr>
+          <p:cNvPr id="5" name="TextBox 4"/>
+          <p:cNvSpPr txBox="1"/>
+          <p:nvPr/>
+        </p:nvSpPr>
+        <p:spPr>
+          <a:xfrm>
+            <a:off x="731520" y="1554480"/>
+            <a:ext cx="5486400" cy="4663440"/>
+          </a:xfrm>
+          <a:prstGeom prst="rect">
+            <a:avLst/>
+          </a:prstGeom>
+          <a:noFill/>
+        </p:spPr>
+        <p:txBody>
+          <a:bodyPr wrap="square" lIns="0" rIns="0" tIns="0" anchor="t">
+            <a:spAutoFit/>
+          </a:bodyPr>
+          <a:lstStyle/>
+          <a:p>
+            <a:pPr>
+              <a:spcAft>
+                <a:spcPts val="800"/>
+              </a:spcAft>
+              <a:defRPr sz="1600">
+                <a:solidFill>
+                  <a:srgbClr val="1E293B"/>
+                </a:solidFill>
+                <a:latin typeface="Aptos"/>
+              </a:defRPr>
+            </a:pPr>
+            <a:r>
+              <a:t>La soluci?n queda funcional y estable.</a:t>
+            </a:r>
+          </a:p>
+          <a:p>
+            <a:pPr>
+              <a:spcAft>
+                <a:spcPts val="800"/>
+              </a:spcAft>
+              <a:defRPr sz="1600">
+                <a:solidFill>
+                  <a:srgbClr val="1E293B"/>
+                </a:solidFill>
+                <a:latin typeface="Aptos"/>
+              </a:defRPr>
+            </a:pPr>
+            <a:r>
+              <a:t>Se document? la evidencia de pruebas.</a:t>
+            </a:r>
+          </a:p>
+          <a:p>
+            <a:pPr>
+              <a:spcAft>
+                <a:spcPts val="800"/>
+              </a:spcAft>
+              <a:defRPr sz="1600">
+                <a:solidFill>
+                  <a:srgbClr val="1E293B"/>
+                </a:solidFill>
+                <a:latin typeface="Aptos"/>
+              </a:defRPr>
+            </a:pPr>
+            <a:r>
+              <a:t>Se reforz? la limpieza de artefactos no ?tiles.</a:t>
+            </a:r>
+          </a:p>
+          <a:p>
+            <a:pPr>
+              <a:spcAft>
+                <a:spcPts val="800"/>
+              </a:spcAft>
+              <a:defRPr sz="1600">
+                <a:solidFill>
+                  <a:srgbClr val="1E293B"/>
+                </a:solidFill>
+                <a:latin typeface="Aptos"/>
+              </a:defRPr>
+            </a:pPr>
+            <a:r>
+              <a:t>Se dej? el flujo listo para grabaci?n y defensa.</a:t>
+            </a:r>
+          </a:p>
+        </p:txBody>
+      </p:sp>
+      <p:sp>
+        <p:nvSpPr>
+          <p:cNvPr id="6" name="Rounded Rectangle 5"/>
+          <p:cNvSpPr/>
+          <p:nvPr/>
+        </p:nvSpPr>
+        <p:spPr>
+          <a:xfrm>
+            <a:off x="6400800" y="1143000"/>
+            <a:ext cx="4892040" cy="4800600"/>
+          </a:xfrm>
+          <a:prstGeom prst="roundRect">
+            <a:avLst/>
+          </a:prstGeom>
+          <a:solidFill>
+            <a:srgbClr val="F6F9FC"/>
+          </a:solidFill>
+          <a:ln>
+            <a:solidFill>
+              <a:srgbClr val="DCE6F2"/>
+            </a:solidFill>
+          </a:ln>
+        </p:spPr>
+        <p:style>
+          <a:lnRef idx="1">
+            <a:schemeClr val="accent1"/>
+          </a:lnRef>
+          <a:fillRef idx="3">
+            <a:schemeClr val="accent1"/>
+          </a:fillRef>
+          <a:effectRef idx="2">
+            <a:schemeClr val="accent1"/>
+          </a:effectRef>
+          <a:fontRef idx="minor">
+            <a:schemeClr val="lt1"/>
+          </a:fontRef>
+        </p:style>
+        <p:txBody>
+          <a:bodyPr rtlCol="0" anchor="ctr" lIns="228600" tIns="164592"/>
+          <a:lstStyle/>
+          <a:p>
+            <a:pPr algn="ctr">
+              <a:defRPr sz="1800" b="1">
+                <a:solidFill>
+                  <a:srgbClr val="112A4A"/>
+                </a:solidFill>
+              </a:defRPr>
+            </a:pPr>
+            <a:r>
+              <a:t>Qu? conviene decir</a:t>
+            </a:r>
+          </a:p>
+          <a:p>
+            <a:pPr>
+              <a:spcAft>
+                <a:spcPts val="800"/>
+              </a:spcAft>
+              <a:defRPr sz="1600">
+                <a:solidFill>
+                  <a:srgbClr val="1E293B"/>
+                </a:solidFill>
+              </a:defRPr>
+            </a:pPr>
+            <a:r>
+              <a:t>Se identificaron hallazgos durante el proceso.</a:t>
+            </a:r>
+          </a:p>
+          <a:p>
+            <a:pPr>
+              <a:spcAft>
+                <a:spcPts val="800"/>
+              </a:spcAft>
+              <a:defRPr sz="1600">
+                <a:solidFill>
+                  <a:srgbClr val="1E293B"/>
+                </a:solidFill>
+              </a:defRPr>
+            </a:pPr>
+            <a:r>
+              <a:t>Se aplicaron mejoras concretas y se revalidaron.</a:t>
+            </a:r>
+          </a:p>
+          <a:p>
+            <a:pPr>
+              <a:spcAft>
+                <a:spcPts val="800"/>
+              </a:spcAft>
+              <a:defRPr sz="1600">
+                <a:solidFill>
+                  <a:srgbClr val="1E293B"/>
+                </a:solidFill>
+              </a:defRPr>
+            </a:pPr>
+            <a:r>
+              <a:t>La plataforma queda preparada para demostrar valor.</a:t>
+            </a:r>
+          </a:p>
+        </p:txBody>
+      </p:sp>
+      <p:sp>
+        <p:nvSpPr>
+          <p:cNvPr id="7" name="TextBox 6"/>
+          <p:cNvSpPr txBox="1"/>
+          <p:nvPr/>
+        </p:nvSpPr>
+        <p:spPr>
+          <a:xfrm>
+            <a:off x="502920" y="6400800"/>
+            <a:ext cx="10972800" cy="228600"/>
+          </a:xfrm>
+          <a:prstGeom prst="rect">
+            <a:avLst/>
+          </a:prstGeom>
+          <a:noFill/>
+        </p:spPr>
+        <p:txBody>
+          <a:bodyPr wrap="none">
+            <a:spAutoFit/>
+          </a:bodyPr>
+          <a:lstStyle/>
+          <a:p>
+            <a:pPr algn="r">
+              <a:defRPr sz="900">
+                <a:solidFill>
+                  <a:srgbClr val="64748B"/>
+                </a:solidFill>
+              </a:defRPr>
+            </a:pPr>
+            <a:r>
+              <a:t>RedNorte | Parcial 3</a:t>
             </a:r>
           </a:p>
         </p:txBody>
@@ -3619,6 +6133,14 @@
 <file path=ppt/slides/slide8.xml><?xml version="1.0" encoding="utf-8"?>
 <p:sld xmlns:a="http://schemas.openxmlformats.org/drawingml/2006/main" xmlns:p="http://schemas.openxmlformats.org/presentationml/2006/main" xmlns:r="http://schemas.openxmlformats.org/officeDocument/2006/relationships">
   <p:cSld>
+    <p:bg>
+      <p:bgPr>
+        <a:solidFill>
+          <a:srgbClr val="112A4A"/>
+        </a:solidFill>
+        <a:effectLst/>
+      </p:bgPr>
+    </p:bg>
     <p:spTree>
       <p:nvGrpSpPr>
         <p:cNvPr id="1" name=""/>
@@ -3628,132 +6150,176 @@
       <p:grpSpPr/>
       <p:sp>
         <p:nvSpPr>
-          <p:cNvPr id="2" name="Title 1"/>
-          <p:cNvSpPr>
-            <a:spLocks noGrp="1"/>
-          </p:cNvSpPr>
-          <p:nvPr>
-            <p:ph type="title"/>
-          </p:nvPr>
-        </p:nvSpPr>
-        <p:spPr/>
-        <p:txBody>
-          <a:bodyPr/>
-          <a:lstStyle/>
-          <a:p>
-            <a:r>
-              <a:t>7. Evidencia para defensa</a:t>
-            </a:r>
-          </a:p>
-        </p:txBody>
-      </p:sp>
-      <p:sp>
-        <p:nvSpPr>
-          <p:cNvPr id="3" name="Content Placeholder 2"/>
-          <p:cNvSpPr>
-            <a:spLocks noGrp="1"/>
-          </p:cNvSpPr>
-          <p:nvPr>
-            <p:ph idx="1"/>
-          </p:nvPr>
-        </p:nvSpPr>
-        <p:spPr/>
-        <p:txBody>
-          <a:bodyPr/>
-          <a:lstStyle/>
-          <a:p>
-            <a:r>
-              <a:t>Diagrama de arquitectura</a:t>
-            </a:r>
-          </a:p>
-          <a:p>
-            <a:r>
-              <a:t>Demo UI y API (Postman/OpenAPI)</a:t>
-            </a:r>
-          </a:p>
-          <a:p>
-            <a:r>
-              <a:t>Reportes unitarios + integracion + e2e</a:t>
-            </a:r>
-          </a:p>
-          <a:p>
-            <a:r>
-              <a:t>Bugs detectados y mejoras aplicadas</a:t>
-            </a:r>
-          </a:p>
-        </p:txBody>
-      </p:sp>
-    </p:spTree>
-  </p:cSld>
-  <p:clrMapOvr>
-    <a:masterClrMapping/>
-  </p:clrMapOvr>
-</p:sld>
-</file>
-
-<file path=ppt/slides/slide9.xml><?xml version="1.0" encoding="utf-8"?>
-<p:sld xmlns:a="http://schemas.openxmlformats.org/drawingml/2006/main" xmlns:p="http://schemas.openxmlformats.org/presentationml/2006/main" xmlns:r="http://schemas.openxmlformats.org/officeDocument/2006/relationships">
-  <p:cSld>
-    <p:spTree>
-      <p:nvGrpSpPr>
-        <p:cNvPr id="1" name=""/>
-        <p:cNvGrpSpPr/>
-        <p:nvPr/>
-      </p:nvGrpSpPr>
-      <p:grpSpPr/>
-      <p:sp>
-        <p:nvSpPr>
-          <p:cNvPr id="2" name="Title 1"/>
-          <p:cNvSpPr>
-            <a:spLocks noGrp="1"/>
-          </p:cNvSpPr>
-          <p:nvPr>
-            <p:ph type="title"/>
-          </p:nvPr>
-        </p:nvSpPr>
-        <p:spPr/>
-        <p:txBody>
-          <a:bodyPr/>
-          <a:lstStyle/>
-          <a:p>
-            <a:r>
-              <a:t>8. Conclusiones</a:t>
-            </a:r>
-          </a:p>
-        </p:txBody>
-      </p:sp>
-      <p:sp>
-        <p:nvSpPr>
-          <p:cNvPr id="3" name="Content Placeholder 2"/>
-          <p:cNvSpPr>
-            <a:spLocks noGrp="1"/>
-          </p:cNvSpPr>
-          <p:nvPr>
-            <p:ph idx="1"/>
-          </p:nvPr>
-        </p:nvSpPr>
-        <p:spPr/>
-        <p:txBody>
-          <a:bodyPr/>
-          <a:lstStyle/>
-          <a:p>
-            <a:r>
-              <a:t>Entrega cubre unitarias, integracion y end-to-end</a:t>
-            </a:r>
-          </a:p>
-          <a:p>
-            <a:r>
-              <a:t>Pruebas enfocadas en procesos criticos del negocio</a:t>
-            </a:r>
-          </a:p>
-          <a:p>
-            <a:r>
-              <a:t>Existe trazabilidad de resultados y mejoras</a:t>
-            </a:r>
-          </a:p>
-          <a:p>
-            <a:r>
-              <a:t>Sistema listo para defensa oral con evidencia tecnica</a:t>
+          <p:cNvPr id="2" name="Rounded Rectangle 1"/>
+          <p:cNvSpPr/>
+          <p:nvPr/>
+        </p:nvSpPr>
+        <p:spPr>
+          <a:xfrm>
+            <a:off x="1097280" y="914400"/>
+            <a:ext cx="9966960" cy="4572000"/>
+          </a:xfrm>
+          <a:prstGeom prst="roundRect">
+            <a:avLst/>
+          </a:prstGeom>
+          <a:solidFill>
+            <a:srgbClr val="FFFFFF"/>
+          </a:solidFill>
+          <a:ln>
+            <a:noFill/>
+          </a:ln>
+        </p:spPr>
+        <p:style>
+          <a:lnRef idx="1">
+            <a:schemeClr val="accent1"/>
+          </a:lnRef>
+          <a:fillRef idx="3">
+            <a:schemeClr val="accent1"/>
+          </a:fillRef>
+          <a:effectRef idx="2">
+            <a:schemeClr val="accent1"/>
+          </a:effectRef>
+          <a:fontRef idx="minor">
+            <a:schemeClr val="lt1"/>
+          </a:fontRef>
+        </p:style>
+        <p:txBody>
+          <a:bodyPr rtlCol="0" anchor="ctr" lIns="365760" rIns="365760" tIns="320040"/>
+          <a:lstStyle/>
+          <a:p>
+            <a:pPr algn="ctr">
+              <a:defRPr sz="2800" b="1">
+                <a:solidFill>
+                  <a:srgbClr val="112A4A"/>
+                </a:solidFill>
+              </a:defRPr>
+            </a:pPr>
+            <a:r>
+              <a:t>Cierre</a:t>
+            </a:r>
+          </a:p>
+          <a:p>
+            <a:pPr algn="ctr">
+              <a:defRPr sz="2000">
+                <a:solidFill>
+                  <a:srgbClr val="147E7C"/>
+                </a:solidFill>
+              </a:defRPr>
+            </a:pPr>
+            <a:r>
+              <a:t>RedNorte queda presentado como una soluci?n funcional, documentada y validada.</a:t>
+            </a:r>
+          </a:p>
+          <a:p>
+            <a:pPr>
+              <a:spcAft>
+                <a:spcPts val="600"/>
+              </a:spcAft>
+              <a:defRPr sz="1800">
+                <a:solidFill>
+                  <a:srgbClr val="1E293B"/>
+                </a:solidFill>
+              </a:defRPr>
+            </a:pPr>
+            <a:r>
+              <a:t>Arquitectura de microservicios clara.</a:t>
+            </a:r>
+          </a:p>
+          <a:p>
+            <a:pPr>
+              <a:spcAft>
+                <a:spcPts val="600"/>
+              </a:spcAft>
+              <a:defRPr sz="1800">
+                <a:solidFill>
+                  <a:srgbClr val="1E293B"/>
+                </a:solidFill>
+              </a:defRPr>
+            </a:pPr>
+            <a:r>
+              <a:t>Flujo de negocio demostrado de punta a punta.</a:t>
+            </a:r>
+          </a:p>
+          <a:p>
+            <a:pPr>
+              <a:spcAft>
+                <a:spcPts val="600"/>
+              </a:spcAft>
+              <a:defRPr sz="1800">
+                <a:solidFill>
+                  <a:srgbClr val="1E293B"/>
+                </a:solidFill>
+              </a:defRPr>
+            </a:pPr>
+            <a:r>
+              <a:t>Pruebas obligatorias cubiertas con evidencia.</a:t>
+            </a:r>
+          </a:p>
+          <a:p>
+            <a:pPr>
+              <a:spcAft>
+                <a:spcPts val="600"/>
+              </a:spcAft>
+              <a:defRPr sz="1800">
+                <a:solidFill>
+                  <a:srgbClr val="1E293B"/>
+                </a:solidFill>
+              </a:defRPr>
+            </a:pPr>
+            <a:r>
+              <a:t>Presentaci?n lista para acompa?ar el video.</a:t>
+            </a:r>
+          </a:p>
+        </p:txBody>
+      </p:sp>
+      <p:sp>
+        <p:nvSpPr>
+          <p:cNvPr id="3" name="Rounded Rectangle 2"/>
+          <p:cNvSpPr/>
+          <p:nvPr/>
+        </p:nvSpPr>
+        <p:spPr>
+          <a:xfrm>
+            <a:off x="1828800" y="5669280"/>
+            <a:ext cx="8503920" cy="594360"/>
+          </a:xfrm>
+          <a:prstGeom prst="roundRect">
+            <a:avLst/>
+          </a:prstGeom>
+          <a:solidFill>
+            <a:srgbClr val="F2B02D"/>
+          </a:solidFill>
+          <a:ln>
+            <a:noFill/>
+          </a:ln>
+        </p:spPr>
+        <p:style>
+          <a:lnRef idx="1">
+            <a:schemeClr val="accent1"/>
+          </a:lnRef>
+          <a:fillRef idx="3">
+            <a:schemeClr val="accent1"/>
+          </a:fillRef>
+          <a:effectRef idx="2">
+            <a:schemeClr val="accent1"/>
+          </a:effectRef>
+          <a:fontRef idx="minor">
+            <a:schemeClr val="lt1"/>
+          </a:fontRef>
+        </p:style>
+        <p:txBody>
+          <a:bodyPr rtlCol="0" anchor="ctr"/>
+          <a:lstStyle/>
+          <a:p>
+            <a:pPr algn="ctr">
+              <a:defRPr sz="1400" b="1">
+                <a:solidFill>
+                  <a:srgbClr val="FFFFFF"/>
+                </a:solidFill>
+              </a:defRPr>
+            </a:pPr>
+            <a:r>
+              <a:t>Soporte visual para el video de exposici?n y para la revisi?n de la pauta.</a:t>
             </a:r>
           </a:p>
         </p:txBody>

</xml_diff>